<commit_message>
Remove obsolete files: deleted the compliance report JSON, index HTML, and AI connection test script to streamline the project structure.
</commit_message>
<xml_diff>
--- a/OSCAL_Compliance_Tool_Demo.pptx
+++ b/OSCAL_Compliance_Tool_Demo.pptx
@@ -204,9 +204,6 @@
         </p15:guide>
       </p15:sldGuideLst>
     </p:ext>
-    <p:ext uri="{2D200454-40CA-4A62-9FC3-DE9A4176ACB9}">
-      <p15:notesGuideLst xmlns:p15="http://schemas.microsoft.com/office/powerpoint/2012/main"/>
-    </p:ext>
   </p:extLst>
 </p:presentation>
 </file>
@@ -230,112 +227,35 @@
 <file path=ppt/changesInfos/changesInfo1.xml><?xml version="1.0" encoding="utf-8"?>
 <pc:chgInfo xmlns:a="http://schemas.openxmlformats.org/drawingml/2006/main" xmlns:r="http://schemas.openxmlformats.org/officeDocument/2006/relationships" xmlns:ac="http://schemas.microsoft.com/office/drawing/2013/main/command" xmlns:pc="http://schemas.microsoft.com/office/powerpoint/2013/main/command">
   <pc:docChgLst>
-    <pc:chgData clId="Web-{77BE7CFD-D5EE-4162-867B-83413E8BA38D}"/>
-    <pc:docChg chg="addSld delSld modSld addSection">
-      <pc:chgData name="" userId="" providerId="" clId="Web-{77BE7CFD-D5EE-4162-867B-83413E8BA38D}" dt="2025-11-30T22:26:16.262" v="17" actId="34807"/>
+    <pc:chgData name="Mukesh Kesharwani" userId="S::mkesharw@adobe.com::dd4ce3d9-e302-45d5-927d-ab066c339129" providerId="AD" clId="Web-{D2D4ACC2-162D-9CF6-58FF-A6039CA57F2D}"/>
+    <pc:docChg chg="addSld modSld sldOrd modSection">
+      <pc:chgData name="Mukesh Kesharwani" userId="S::mkesharw@adobe.com::dd4ce3d9-e302-45d5-927d-ab066c339129" providerId="AD" clId="Web-{D2D4ACC2-162D-9CF6-58FF-A6039CA57F2D}" dt="2025-12-02T23:14:51.207" v="47"/>
       <pc:docMkLst>
         <pc:docMk/>
       </pc:docMkLst>
-      <pc:sldChg chg="modSp add mod modClrScheme addAnim chgLayout">
-        <pc:chgData name="" userId="" providerId="" clId="Web-{77BE7CFD-D5EE-4162-867B-83413E8BA38D}" dt="2025-11-30T22:26:16.262" v="4" actId="34807"/>
-        <pc:sldMkLst>
-          <pc:docMk/>
-          <pc:sldMk cId="4169979767" sldId="2561"/>
-        </pc:sldMkLst>
-        <pc:spChg chg="mod">
-          <ac:chgData name="" userId="" providerId="" clId="Web-{77BE7CFD-D5EE-4162-867B-83413E8BA38D}" dt="2025-11-30T22:26:16.262" v="1" actId="34807"/>
-          <ac:spMkLst>
-            <pc:docMk/>
-            <pc:sldMk cId="4169979767" sldId="2561"/>
-            <ac:spMk id="2" creationId="{AA6E19F0-54F5-1E64-2237-B33646A525F4}"/>
-          </ac:spMkLst>
-        </pc:spChg>
-        <pc:spChg chg="mod">
-          <ac:chgData name="" userId="" providerId="" clId="Web-{77BE7CFD-D5EE-4162-867B-83413E8BA38D}" dt="2025-11-30T22:26:16.262" v="1" actId="34807"/>
-          <ac:spMkLst>
-            <pc:docMk/>
-            <pc:sldMk cId="4169979767" sldId="2561"/>
-            <ac:spMk id="3" creationId="{0457094F-EBFA-385A-C0CF-F5D90FCCBAE0}"/>
-          </ac:spMkLst>
-        </pc:spChg>
-        <pc:picChg chg="mod">
-          <ac:chgData name="" userId="" providerId="" clId="Web-{77BE7CFD-D5EE-4162-867B-83413E8BA38D}" dt="2025-11-30T22:26:16.262" v="1" actId="34807"/>
-          <ac:picMkLst>
-            <pc:docMk/>
-            <pc:sldMk cId="4169979767" sldId="2561"/>
-            <ac:picMk id="4" creationId="{998C3406-656D-4B21-BFDB-D54370CA178E}"/>
-          </ac:picMkLst>
-        </pc:picChg>
-      </pc:sldChg>
-      <pc:sldChg chg="modSp add mod modTransition addAnim chgLayout">
-        <pc:chgData name="" userId="" providerId="" clId="Web-{77BE7CFD-D5EE-4162-867B-83413E8BA38D}" dt="2025-11-30T22:26:16.262" v="5" actId="34807"/>
-        <pc:sldMkLst>
-          <pc:docMk/>
-          <pc:sldMk cId="1352343287" sldId="2562"/>
-        </pc:sldMkLst>
-        <pc:spChg chg="mod">
-          <ac:chgData name="" userId="" providerId="" clId="Web-{77BE7CFD-D5EE-4162-867B-83413E8BA38D}" dt="2025-11-30T22:26:16.262" v="1" actId="34807"/>
-          <ac:spMkLst>
-            <pc:docMk/>
-            <pc:sldMk cId="1352343287" sldId="2562"/>
-            <ac:spMk id="2" creationId="{AEC76E86-37EA-ECC3-4AD8-E133388A266B}"/>
-          </ac:spMkLst>
-        </pc:spChg>
-      </pc:sldChg>
-      <pc:sldChg chg="modSp add mod modTransition modClrScheme addAnim chgLayout">
-        <pc:chgData name="" userId="" providerId="" clId="Web-{77BE7CFD-D5EE-4162-867B-83413E8BA38D}" dt="2025-11-30T22:26:16.262" v="6" actId="34807"/>
+      <pc:sldChg chg="modSp">
+        <pc:chgData name="Mukesh Kesharwani" userId="S::mkesharw@adobe.com::dd4ce3d9-e302-45d5-927d-ab066c339129" providerId="AD" clId="Web-{D2D4ACC2-162D-9CF6-58FF-A6039CA57F2D}" dt="2025-12-02T23:08:49.400" v="12" actId="20577"/>
         <pc:sldMkLst>
           <pc:docMk/>
           <pc:sldMk cId="728984326" sldId="2563"/>
         </pc:sldMkLst>
         <pc:spChg chg="mod">
-          <ac:chgData name="" userId="" providerId="" clId="Web-{77BE7CFD-D5EE-4162-867B-83413E8BA38D}" dt="2025-11-30T22:26:16.262" v="1" actId="34807"/>
-          <ac:spMkLst>
-            <pc:docMk/>
-            <pc:sldMk cId="728984326" sldId="2563"/>
-            <ac:spMk id="2" creationId="{81136E39-AA3A-344A-3B1B-3F20C5A7EE49}"/>
-          </ac:spMkLst>
-        </pc:spChg>
-        <pc:spChg chg="mod">
-          <ac:chgData name="" userId="" providerId="" clId="Web-{77BE7CFD-D5EE-4162-867B-83413E8BA38D}" dt="2025-11-30T22:26:16.262" v="1" actId="34807"/>
+          <ac:chgData name="Mukesh Kesharwani" userId="S::mkesharw@adobe.com::dd4ce3d9-e302-45d5-927d-ab066c339129" providerId="AD" clId="Web-{D2D4ACC2-162D-9CF6-58FF-A6039CA57F2D}" dt="2025-12-02T23:08:49.400" v="12" actId="20577"/>
           <ac:spMkLst>
             <pc:docMk/>
             <pc:sldMk cId="728984326" sldId="2563"/>
             <ac:spMk id="4" creationId="{7A138BE7-90C6-0303-4EC0-86D7AC552D32}"/>
           </ac:spMkLst>
         </pc:spChg>
-        <pc:picChg chg="mod">
-          <ac:chgData name="" userId="" providerId="" clId="Web-{77BE7CFD-D5EE-4162-867B-83413E8BA38D}" dt="2025-11-30T22:26:16.262" v="1" actId="34807"/>
-          <ac:picMkLst>
-            <pc:docMk/>
-            <pc:sldMk cId="728984326" sldId="2563"/>
-            <ac:picMk id="5" creationId="{B643B872-4418-4744-8E25-A016FCB9312E}"/>
-          </ac:picMkLst>
-        </pc:picChg>
       </pc:sldChg>
-      <pc:sldChg chg="modSp add mod modTransition addAnim chgLayout">
-        <pc:chgData name="" userId="" providerId="" clId="Web-{77BE7CFD-D5EE-4162-867B-83413E8BA38D}" dt="2025-11-30T22:26:16.262" v="7" actId="34807"/>
-        <pc:sldMkLst>
-          <pc:docMk/>
-          <pc:sldMk cId="747674798" sldId="2564"/>
-        </pc:sldMkLst>
-        <pc:spChg chg="mod">
-          <ac:chgData name="" userId="" providerId="" clId="Web-{77BE7CFD-D5EE-4162-867B-83413E8BA38D}" dt="2025-11-30T22:26:16.262" v="1" actId="34807"/>
-          <ac:spMkLst>
-            <pc:docMk/>
-            <pc:sldMk cId="747674798" sldId="2564"/>
-            <ac:spMk id="2" creationId="{0B25FC94-B622-F45A-7D57-48F7D08AEDB1}"/>
-          </ac:spMkLst>
-        </pc:spChg>
-      </pc:sldChg>
-      <pc:sldChg chg="modSp add mod modTransition modClrScheme addAnim chgLayout">
-        <pc:chgData name="" userId="" providerId="" clId="Web-{77BE7CFD-D5EE-4162-867B-83413E8BA38D}" dt="2025-11-30T22:26:16.262" v="8" actId="34807"/>
+      <pc:sldChg chg="modSp">
+        <pc:chgData name="Mukesh Kesharwani" userId="S::mkesharw@adobe.com::dd4ce3d9-e302-45d5-927d-ab066c339129" providerId="AD" clId="Web-{D2D4ACC2-162D-9CF6-58FF-A6039CA57F2D}" dt="2025-12-02T23:10:12.792" v="28" actId="20577"/>
         <pc:sldMkLst>
           <pc:docMk/>
           <pc:sldMk cId="2742718792" sldId="2565"/>
         </pc:sldMkLst>
         <pc:spChg chg="mod">
-          <ac:chgData name="" userId="" providerId="" clId="Web-{77BE7CFD-D5EE-4162-867B-83413E8BA38D}" dt="2025-11-30T22:26:16.262" v="1" actId="34807"/>
+          <ac:chgData name="Mukesh Kesharwani" userId="S::mkesharw@adobe.com::dd4ce3d9-e302-45d5-927d-ab066c339129" providerId="AD" clId="Web-{D2D4ACC2-162D-9CF6-58FF-A6039CA57F2D}" dt="2025-12-02T23:09:00.603" v="13" actId="14100"/>
           <ac:spMkLst>
             <pc:docMk/>
             <pc:sldMk cId="2742718792" sldId="2565"/>
@@ -343,225 +263,95 @@
           </ac:spMkLst>
         </pc:spChg>
         <pc:spChg chg="mod">
-          <ac:chgData name="" userId="" providerId="" clId="Web-{77BE7CFD-D5EE-4162-867B-83413E8BA38D}" dt="2025-11-30T22:26:16.262" v="1" actId="34807"/>
+          <ac:chgData name="Mukesh Kesharwani" userId="S::mkesharw@adobe.com::dd4ce3d9-e302-45d5-927d-ab066c339129" providerId="AD" clId="Web-{D2D4ACC2-162D-9CF6-58FF-A6039CA57F2D}" dt="2025-12-02T23:10:12.792" v="28" actId="20577"/>
           <ac:spMkLst>
             <pc:docMk/>
             <pc:sldMk cId="2742718792" sldId="2565"/>
             <ac:spMk id="4" creationId="{197970EA-EBDC-976C-C7C1-986F1E12053D}"/>
           </ac:spMkLst>
         </pc:spChg>
-        <pc:picChg chg="mod">
-          <ac:chgData name="" userId="" providerId="" clId="Web-{77BE7CFD-D5EE-4162-867B-83413E8BA38D}" dt="2025-11-30T22:26:16.262" v="1" actId="34807"/>
-          <ac:picMkLst>
-            <pc:docMk/>
-            <pc:sldMk cId="2742718792" sldId="2565"/>
-            <ac:picMk id="5" creationId="{F3F6CAF3-0383-4E86-9205-F349FEFC003B}"/>
-          </ac:picMkLst>
-        </pc:picChg>
       </pc:sldChg>
-      <pc:sldChg chg="modSp add mod modTransition addAnim chgLayout">
-        <pc:chgData name="" userId="" providerId="" clId="Web-{77BE7CFD-D5EE-4162-867B-83413E8BA38D}" dt="2025-11-30T22:26:16.262" v="9" actId="34807"/>
+      <pc:sldChg chg="ord">
+        <pc:chgData name="Mukesh Kesharwani" userId="S::mkesharw@adobe.com::dd4ce3d9-e302-45d5-927d-ab066c339129" providerId="AD" clId="Web-{D2D4ACC2-162D-9CF6-58FF-A6039CA57F2D}" dt="2025-12-02T23:13:55.847" v="37"/>
         <pc:sldMkLst>
           <pc:docMk/>
-          <pc:sldMk cId="476014375" sldId="2566"/>
+          <pc:sldMk cId="3337152857" sldId="2577"/>
+        </pc:sldMkLst>
+      </pc:sldChg>
+      <pc:sldChg chg="modSp">
+        <pc:chgData name="Mukesh Kesharwani" userId="S::mkesharw@adobe.com::dd4ce3d9-e302-45d5-927d-ab066c339129" providerId="AD" clId="Web-{D2D4ACC2-162D-9CF6-58FF-A6039CA57F2D}" dt="2025-12-02T23:12:45.440" v="35" actId="20577"/>
+        <pc:sldMkLst>
+          <pc:docMk/>
+          <pc:sldMk cId="2644275766" sldId="2578"/>
         </pc:sldMkLst>
         <pc:spChg chg="mod">
-          <ac:chgData name="" userId="" providerId="" clId="Web-{77BE7CFD-D5EE-4162-867B-83413E8BA38D}" dt="2025-11-30T22:26:16.262" v="1" actId="34807"/>
+          <ac:chgData name="Mukesh Kesharwani" userId="S::mkesharw@adobe.com::dd4ce3d9-e302-45d5-927d-ab066c339129" providerId="AD" clId="Web-{D2D4ACC2-162D-9CF6-58FF-A6039CA57F2D}" dt="2025-12-02T23:12:45.440" v="35" actId="20577"/>
           <ac:spMkLst>
             <pc:docMk/>
-            <pc:sldMk cId="476014375" sldId="2566"/>
-            <ac:spMk id="2" creationId="{347AD309-6F4E-FEF4-32DE-2C8FB15E35EF}"/>
+            <pc:sldMk cId="2644275766" sldId="2578"/>
+            <ac:spMk id="4" creationId="{8066E1C7-3B8E-723E-2516-F9CE89A4D703}"/>
           </ac:spMkLst>
         </pc:spChg>
       </pc:sldChg>
-      <pc:sldChg chg="modSp add mod modTransition">
-        <pc:chgData name="" userId="" providerId="" clId="Web-{77BE7CFD-D5EE-4162-867B-83413E8BA38D}" dt="2025-11-30T22:26:16.262" v="1" actId="34807"/>
+      <pc:sldChg chg="modSp add replId">
+        <pc:chgData name="Mukesh Kesharwani" userId="S::mkesharw@adobe.com::dd4ce3d9-e302-45d5-927d-ab066c339129" providerId="AD" clId="Web-{D2D4ACC2-162D-9CF6-58FF-A6039CA57F2D}" dt="2025-12-02T23:14:10.753" v="42" actId="20577"/>
         <pc:sldMkLst>
           <pc:docMk/>
-          <pc:sldMk cId="1084978174" sldId="2567"/>
+          <pc:sldMk cId="873167342" sldId="2579"/>
         </pc:sldMkLst>
         <pc:spChg chg="mod">
-          <ac:chgData name="" userId="" providerId="" clId="Web-{77BE7CFD-D5EE-4162-867B-83413E8BA38D}" dt="2025-11-30T22:26:16.262" v="1" actId="34807"/>
+          <ac:chgData name="Mukesh Kesharwani" userId="S::mkesharw@adobe.com::dd4ce3d9-e302-45d5-927d-ab066c339129" providerId="AD" clId="Web-{D2D4ACC2-162D-9CF6-58FF-A6039CA57F2D}" dt="2025-12-02T23:14:10.753" v="42" actId="20577"/>
           <ac:spMkLst>
             <pc:docMk/>
-            <pc:sldMk cId="1084978174" sldId="2567"/>
-            <ac:spMk id="2" creationId="{28194AC3-1708-1834-DB2A-966777B913D5}"/>
-          </ac:spMkLst>
-        </pc:spChg>
-        <pc:graphicFrameChg chg="mod modGraphic">
-          <ac:chgData name="" userId="" providerId="" clId="Web-{77BE7CFD-D5EE-4162-867B-83413E8BA38D}" dt="2025-11-30T22:26:16.262" v="1" actId="34807"/>
-          <ac:graphicFrameMkLst>
-            <pc:docMk/>
-            <pc:sldMk cId="1084978174" sldId="2567"/>
-            <ac:graphicFrameMk id="4" creationId="{C949BDD0-2D54-4182-A65F-F4805EB5294D}"/>
-          </ac:graphicFrameMkLst>
-        </pc:graphicFrameChg>
-      </pc:sldChg>
-      <pc:sldChg chg="modSp add mod modTransition addAnim chgLayout">
-        <pc:chgData name="" userId="" providerId="" clId="Web-{77BE7CFD-D5EE-4162-867B-83413E8BA38D}" dt="2025-11-30T22:26:16.262" v="10" actId="34807"/>
-        <pc:sldMkLst>
-          <pc:docMk/>
-          <pc:sldMk cId="4274179907" sldId="2568"/>
-        </pc:sldMkLst>
-        <pc:spChg chg="mod">
-          <ac:chgData name="" userId="" providerId="" clId="Web-{77BE7CFD-D5EE-4162-867B-83413E8BA38D}" dt="2025-11-30T22:26:16.262" v="1" actId="34807"/>
-          <ac:spMkLst>
-            <pc:docMk/>
-            <pc:sldMk cId="4274179907" sldId="2568"/>
-            <ac:spMk id="2" creationId="{B646F812-1C4D-EF58-F76D-611E324DF8AE}"/>
+            <pc:sldMk cId="873167342" sldId="2579"/>
+            <ac:spMk id="2" creationId="{380DE5E1-6333-3351-3696-896CE3B41693}"/>
           </ac:spMkLst>
         </pc:spChg>
       </pc:sldChg>
-      <pc:sldChg chg="modSp add mod modTransition modClrScheme addAnim chgLayout">
-        <pc:chgData name="" userId="" providerId="" clId="Web-{77BE7CFD-D5EE-4162-867B-83413E8BA38D}" dt="2025-11-30T22:26:16.262" v="11" actId="34807"/>
+      <pc:sldChg chg="modSp add ord replId">
+        <pc:chgData name="Mukesh Kesharwani" userId="S::mkesharw@adobe.com::dd4ce3d9-e302-45d5-927d-ab066c339129" providerId="AD" clId="Web-{D2D4ACC2-162D-9CF6-58FF-A6039CA57F2D}" dt="2025-12-02T23:14:51.207" v="47"/>
         <pc:sldMkLst>
           <pc:docMk/>
-          <pc:sldMk cId="1833236901" sldId="2569"/>
+          <pc:sldMk cId="2106497024" sldId="2580"/>
         </pc:sldMkLst>
         <pc:spChg chg="mod">
-          <ac:chgData name="" userId="" providerId="" clId="Web-{77BE7CFD-D5EE-4162-867B-83413E8BA38D}" dt="2025-11-30T22:26:16.262" v="1" actId="34807"/>
+          <ac:chgData name="Mukesh Kesharwani" userId="S::mkesharw@adobe.com::dd4ce3d9-e302-45d5-927d-ab066c339129" providerId="AD" clId="Web-{D2D4ACC2-162D-9CF6-58FF-A6039CA57F2D}" dt="2025-12-02T23:14:47.222" v="46" actId="20577"/>
           <ac:spMkLst>
             <pc:docMk/>
-            <pc:sldMk cId="1833236901" sldId="2569"/>
-            <ac:spMk id="2" creationId="{18E5A30A-8BA5-56E7-592F-9C62A3709905}"/>
+            <pc:sldMk cId="2106497024" sldId="2580"/>
+            <ac:spMk id="2" creationId="{7D5AEE16-D6F8-5BF8-320D-6C45C3AEA4FC}"/>
+          </ac:spMkLst>
+        </pc:spChg>
+      </pc:sldChg>
+    </pc:docChg>
+  </pc:docChgLst>
+  <pc:docChgLst>
+    <pc:chgData name="Mukesh Kesharwani" userId="S::mkesharw@adobe.com::dd4ce3d9-e302-45d5-927d-ab066c339129" providerId="AD" clId="Web-{928B1824-6DD8-2986-7595-C67F9F792115}"/>
+    <pc:docChg chg="addSld modSld modSection">
+      <pc:chgData name="Mukesh Kesharwani" userId="S::mkesharw@adobe.com::dd4ce3d9-e302-45d5-927d-ab066c339129" providerId="AD" clId="Web-{928B1824-6DD8-2986-7595-C67F9F792115}" dt="2025-12-02T01:11:57.490" v="67" actId="20577"/>
+      <pc:docMkLst>
+        <pc:docMk/>
+      </pc:docMkLst>
+      <pc:sldChg chg="modSp add replId">
+        <pc:chgData name="Mukesh Kesharwani" userId="S::mkesharw@adobe.com::dd4ce3d9-e302-45d5-927d-ab066c339129" providerId="AD" clId="Web-{928B1824-6DD8-2986-7595-C67F9F792115}" dt="2025-12-02T01:11:57.490" v="67" actId="20577"/>
+        <pc:sldMkLst>
+          <pc:docMk/>
+          <pc:sldMk cId="2644275766" sldId="2578"/>
+        </pc:sldMkLst>
+        <pc:spChg chg="mod">
+          <ac:chgData name="Mukesh Kesharwani" userId="S::mkesharw@adobe.com::dd4ce3d9-e302-45d5-927d-ab066c339129" providerId="AD" clId="Web-{928B1824-6DD8-2986-7595-C67F9F792115}" dt="2025-12-02T01:11:57.490" v="67" actId="20577"/>
+          <ac:spMkLst>
+            <pc:docMk/>
+            <pc:sldMk cId="2644275766" sldId="2578"/>
+            <ac:spMk id="2" creationId="{D85CC109-0F12-1318-02B1-E151F4AEE424}"/>
           </ac:spMkLst>
         </pc:spChg>
         <pc:spChg chg="mod">
-          <ac:chgData name="" userId="" providerId="" clId="Web-{77BE7CFD-D5EE-4162-867B-83413E8BA38D}" dt="2025-11-30T22:26:16.262" v="1" actId="34807"/>
+          <ac:chgData name="Mukesh Kesharwani" userId="S::mkesharw@adobe.com::dd4ce3d9-e302-45d5-927d-ab066c339129" providerId="AD" clId="Web-{928B1824-6DD8-2986-7595-C67F9F792115}" dt="2025-12-02T01:10:12.970" v="40" actId="20577"/>
           <ac:spMkLst>
             <pc:docMk/>
-            <pc:sldMk cId="1833236901" sldId="2569"/>
-            <ac:spMk id="4" creationId="{C7675901-15DD-5F59-DB51-2753AD77E345}"/>
-          </ac:spMkLst>
-        </pc:spChg>
-        <pc:picChg chg="mod ord">
-          <ac:chgData name="" userId="" providerId="" clId="Web-{77BE7CFD-D5EE-4162-867B-83413E8BA38D}" dt="2025-11-30T22:26:16.262" v="1" actId="34807"/>
-          <ac:picMkLst>
-            <pc:docMk/>
-            <pc:sldMk cId="1833236901" sldId="2569"/>
-            <ac:picMk id="5" creationId="{E6C90398-4E13-4C49-AF28-FB57E3201CA8}"/>
-          </ac:picMkLst>
-        </pc:picChg>
-      </pc:sldChg>
-      <pc:sldChg chg="modSp add mod modTransition addAnim chgLayout">
-        <pc:chgData name="" userId="" providerId="" clId="Web-{77BE7CFD-D5EE-4162-867B-83413E8BA38D}" dt="2025-11-30T22:26:16.262" v="12" actId="34807"/>
-        <pc:sldMkLst>
-          <pc:docMk/>
-          <pc:sldMk cId="801341816" sldId="2570"/>
-        </pc:sldMkLst>
-        <pc:spChg chg="mod">
-          <ac:chgData name="" userId="" providerId="" clId="Web-{77BE7CFD-D5EE-4162-867B-83413E8BA38D}" dt="2025-11-30T22:26:16.262" v="1" actId="34807"/>
-          <ac:spMkLst>
-            <pc:docMk/>
-            <pc:sldMk cId="801341816" sldId="2570"/>
-            <ac:spMk id="2" creationId="{C6F6DED7-4462-4CAE-C870-915B89A0701A}"/>
-          </ac:spMkLst>
-        </pc:spChg>
-      </pc:sldChg>
-      <pc:sldChg chg="modSp add mod modTransition modClrScheme addAnim chgLayout">
-        <pc:chgData name="" userId="" providerId="" clId="Web-{77BE7CFD-D5EE-4162-867B-83413E8BA38D}" dt="2025-11-30T22:26:16.262" v="13" actId="34807"/>
-        <pc:sldMkLst>
-          <pc:docMk/>
-          <pc:sldMk cId="1705617485" sldId="2571"/>
-        </pc:sldMkLst>
-        <pc:spChg chg="mod">
-          <ac:chgData name="" userId="" providerId="" clId="Web-{77BE7CFD-D5EE-4162-867B-83413E8BA38D}" dt="2025-11-30T22:26:16.262" v="1" actId="34807"/>
-          <ac:spMkLst>
-            <pc:docMk/>
-            <pc:sldMk cId="1705617485" sldId="2571"/>
-            <ac:spMk id="2" creationId="{4AC11438-E729-E035-7C9A-E8D48F6ABC1D}"/>
-          </ac:spMkLst>
-        </pc:spChg>
-        <pc:spChg chg="mod">
-          <ac:chgData name="" userId="" providerId="" clId="Web-{77BE7CFD-D5EE-4162-867B-83413E8BA38D}" dt="2025-11-30T22:26:16.262" v="1" actId="34807"/>
-          <ac:spMkLst>
-            <pc:docMk/>
-            <pc:sldMk cId="1705617485" sldId="2571"/>
-            <ac:spMk id="4" creationId="{FF5F5206-0C29-02EF-C405-FF8B92D91801}"/>
-          </ac:spMkLst>
-        </pc:spChg>
-        <pc:picChg chg="mod ord">
-          <ac:chgData name="" userId="" providerId="" clId="Web-{77BE7CFD-D5EE-4162-867B-83413E8BA38D}" dt="2025-11-30T22:26:16.262" v="1" actId="34807"/>
-          <ac:picMkLst>
-            <pc:docMk/>
-            <pc:sldMk cId="1705617485" sldId="2571"/>
-            <ac:picMk id="5" creationId="{8A79CBC0-757D-4562-9747-1E7FC3BBD048}"/>
-          </ac:picMkLst>
-        </pc:picChg>
-      </pc:sldChg>
-      <pc:sldChg chg="modSp add mod modTransition addAnim chgLayout">
-        <pc:chgData name="" userId="" providerId="" clId="Web-{77BE7CFD-D5EE-4162-867B-83413E8BA38D}" dt="2025-11-30T22:26:16.262" v="14" actId="34807"/>
-        <pc:sldMkLst>
-          <pc:docMk/>
-          <pc:sldMk cId="1503440935" sldId="2572"/>
-        </pc:sldMkLst>
-        <pc:spChg chg="mod">
-          <ac:chgData name="" userId="" providerId="" clId="Web-{77BE7CFD-D5EE-4162-867B-83413E8BA38D}" dt="2025-11-30T22:26:16.262" v="1" actId="34807"/>
-          <ac:spMkLst>
-            <pc:docMk/>
-            <pc:sldMk cId="1503440935" sldId="2572"/>
-            <ac:spMk id="2" creationId="{1C43BC81-FAB3-4406-6CCE-46366DF437FA}"/>
-          </ac:spMkLst>
-        </pc:spChg>
-      </pc:sldChg>
-      <pc:sldChg chg="modSp add mod modTransition modClrScheme addAnim chgLayout">
-        <pc:chgData name="" userId="" providerId="" clId="Web-{77BE7CFD-D5EE-4162-867B-83413E8BA38D}" dt="2025-11-30T22:26:16.262" v="15" actId="34807"/>
-        <pc:sldMkLst>
-          <pc:docMk/>
-          <pc:sldMk cId="1420985552" sldId="2573"/>
-        </pc:sldMkLst>
-        <pc:spChg chg="mod">
-          <ac:chgData name="" userId="" providerId="" clId="Web-{77BE7CFD-D5EE-4162-867B-83413E8BA38D}" dt="2025-11-30T22:26:16.262" v="1" actId="34807"/>
-          <ac:spMkLst>
-            <pc:docMk/>
-            <pc:sldMk cId="1420985552" sldId="2573"/>
-            <ac:spMk id="2" creationId="{FC5F2222-C4F6-3C84-92E3-65ADA02A79A5}"/>
-          </ac:spMkLst>
-        </pc:spChg>
-        <pc:spChg chg="mod">
-          <ac:chgData name="" userId="" providerId="" clId="Web-{77BE7CFD-D5EE-4162-867B-83413E8BA38D}" dt="2025-11-30T22:26:16.262" v="1" actId="34807"/>
-          <ac:spMkLst>
-            <pc:docMk/>
-            <pc:sldMk cId="1420985552" sldId="2573"/>
-            <ac:spMk id="4" creationId="{04364905-3D06-E066-F88A-B8ED3F85D180}"/>
-          </ac:spMkLst>
-        </pc:spChg>
-      </pc:sldChg>
-      <pc:sldChg chg="modSp add mod modTransition addAnim chgLayout">
-        <pc:chgData name="" userId="" providerId="" clId="Web-{77BE7CFD-D5EE-4162-867B-83413E8BA38D}" dt="2025-11-30T22:26:16.262" v="16" actId="34807"/>
-        <pc:sldMkLst>
-          <pc:docMk/>
-          <pc:sldMk cId="2754576721" sldId="2574"/>
-        </pc:sldMkLst>
-        <pc:spChg chg="mod">
-          <ac:chgData name="" userId="" providerId="" clId="Web-{77BE7CFD-D5EE-4162-867B-83413E8BA38D}" dt="2025-11-30T22:26:16.262" v="1" actId="34807"/>
-          <ac:spMkLst>
-            <pc:docMk/>
-            <pc:sldMk cId="2754576721" sldId="2574"/>
-            <ac:spMk id="2" creationId="{9B3A995C-7916-B79C-C2BD-9271D067263C}"/>
-          </ac:spMkLst>
-        </pc:spChg>
-      </pc:sldChg>
-      <pc:sldChg chg="modSp add mod modTransition modClrScheme addAnim chgLayout">
-        <pc:chgData name="" userId="" providerId="" clId="Web-{77BE7CFD-D5EE-4162-867B-83413E8BA38D}" dt="2025-11-30T22:26:16.262" v="17" actId="34807"/>
-        <pc:sldMkLst>
-          <pc:docMk/>
-          <pc:sldMk cId="1233667441" sldId="2575"/>
-        </pc:sldMkLst>
-        <pc:spChg chg="mod">
-          <ac:chgData name="" userId="" providerId="" clId="Web-{77BE7CFD-D5EE-4162-867B-83413E8BA38D}" dt="2025-11-30T22:26:16.262" v="1" actId="34807"/>
-          <ac:spMkLst>
-            <pc:docMk/>
-            <pc:sldMk cId="1233667441" sldId="2575"/>
-            <ac:spMk id="2" creationId="{EE337F72-21FC-4FD3-B2F9-9535B41F4F13}"/>
-          </ac:spMkLst>
-        </pc:spChg>
-        <pc:spChg chg="mod">
-          <ac:chgData name="" userId="" providerId="" clId="Web-{77BE7CFD-D5EE-4162-867B-83413E8BA38D}" dt="2025-11-30T22:26:16.262" v="1" actId="34807"/>
-          <ac:spMkLst>
-            <pc:docMk/>
-            <pc:sldMk cId="1233667441" sldId="2575"/>
-            <ac:spMk id="4" creationId="{5FF62A10-FECF-775B-6CE7-45995242EAFE}"/>
+            <pc:sldMk cId="2644275766" sldId="2578"/>
+            <ac:spMk id="4" creationId="{8066E1C7-3B8E-723E-2516-F9CE89A4D703}"/>
           </ac:spMkLst>
         </pc:spChg>
       </pc:sldChg>
@@ -989,35 +779,112 @@
     </pc:docChg>
   </pc:docChgLst>
   <pc:docChgLst>
-    <pc:chgData name="Mukesh Kesharwani" userId="S::mkesharw@adobe.com::dd4ce3d9-e302-45d5-927d-ab066c339129" providerId="AD" clId="Web-{D2D4ACC2-162D-9CF6-58FF-A6039CA57F2D}"/>
-    <pc:docChg chg="addSld modSld sldOrd modSection">
-      <pc:chgData name="Mukesh Kesharwani" userId="S::mkesharw@adobe.com::dd4ce3d9-e302-45d5-927d-ab066c339129" providerId="AD" clId="Web-{D2D4ACC2-162D-9CF6-58FF-A6039CA57F2D}" dt="2025-12-02T23:14:51.207" v="47"/>
+    <pc:chgData clId="Web-{77BE7CFD-D5EE-4162-867B-83413E8BA38D}"/>
+    <pc:docChg chg="addSld delSld modSld addSection">
+      <pc:chgData name="" userId="" providerId="" clId="Web-{77BE7CFD-D5EE-4162-867B-83413E8BA38D}" dt="2025-11-30T22:26:16.262" v="17" actId="34807"/>
       <pc:docMkLst>
         <pc:docMk/>
       </pc:docMkLst>
-      <pc:sldChg chg="modSp">
-        <pc:chgData name="Mukesh Kesharwani" userId="S::mkesharw@adobe.com::dd4ce3d9-e302-45d5-927d-ab066c339129" providerId="AD" clId="Web-{D2D4ACC2-162D-9CF6-58FF-A6039CA57F2D}" dt="2025-12-02T23:08:49.400" v="12" actId="20577"/>
+      <pc:sldChg chg="modSp add mod modClrScheme addAnim chgLayout">
+        <pc:chgData name="" userId="" providerId="" clId="Web-{77BE7CFD-D5EE-4162-867B-83413E8BA38D}" dt="2025-11-30T22:26:16.262" v="4" actId="34807"/>
+        <pc:sldMkLst>
+          <pc:docMk/>
+          <pc:sldMk cId="4169979767" sldId="2561"/>
+        </pc:sldMkLst>
+        <pc:spChg chg="mod">
+          <ac:chgData name="" userId="" providerId="" clId="Web-{77BE7CFD-D5EE-4162-867B-83413E8BA38D}" dt="2025-11-30T22:26:16.262" v="1" actId="34807"/>
+          <ac:spMkLst>
+            <pc:docMk/>
+            <pc:sldMk cId="4169979767" sldId="2561"/>
+            <ac:spMk id="2" creationId="{AA6E19F0-54F5-1E64-2237-B33646A525F4}"/>
+          </ac:spMkLst>
+        </pc:spChg>
+        <pc:spChg chg="mod">
+          <ac:chgData name="" userId="" providerId="" clId="Web-{77BE7CFD-D5EE-4162-867B-83413E8BA38D}" dt="2025-11-30T22:26:16.262" v="1" actId="34807"/>
+          <ac:spMkLst>
+            <pc:docMk/>
+            <pc:sldMk cId="4169979767" sldId="2561"/>
+            <ac:spMk id="3" creationId="{0457094F-EBFA-385A-C0CF-F5D90FCCBAE0}"/>
+          </ac:spMkLst>
+        </pc:spChg>
+        <pc:picChg chg="mod">
+          <ac:chgData name="" userId="" providerId="" clId="Web-{77BE7CFD-D5EE-4162-867B-83413E8BA38D}" dt="2025-11-30T22:26:16.262" v="1" actId="34807"/>
+          <ac:picMkLst>
+            <pc:docMk/>
+            <pc:sldMk cId="4169979767" sldId="2561"/>
+            <ac:picMk id="4" creationId="{998C3406-656D-4B21-BFDB-D54370CA178E}"/>
+          </ac:picMkLst>
+        </pc:picChg>
+      </pc:sldChg>
+      <pc:sldChg chg="modSp add mod modTransition addAnim chgLayout">
+        <pc:chgData name="" userId="" providerId="" clId="Web-{77BE7CFD-D5EE-4162-867B-83413E8BA38D}" dt="2025-11-30T22:26:16.262" v="5" actId="34807"/>
+        <pc:sldMkLst>
+          <pc:docMk/>
+          <pc:sldMk cId="1352343287" sldId="2562"/>
+        </pc:sldMkLst>
+        <pc:spChg chg="mod">
+          <ac:chgData name="" userId="" providerId="" clId="Web-{77BE7CFD-D5EE-4162-867B-83413E8BA38D}" dt="2025-11-30T22:26:16.262" v="1" actId="34807"/>
+          <ac:spMkLst>
+            <pc:docMk/>
+            <pc:sldMk cId="1352343287" sldId="2562"/>
+            <ac:spMk id="2" creationId="{AEC76E86-37EA-ECC3-4AD8-E133388A266B}"/>
+          </ac:spMkLst>
+        </pc:spChg>
+      </pc:sldChg>
+      <pc:sldChg chg="modSp add mod modTransition modClrScheme addAnim chgLayout">
+        <pc:chgData name="" userId="" providerId="" clId="Web-{77BE7CFD-D5EE-4162-867B-83413E8BA38D}" dt="2025-11-30T22:26:16.262" v="6" actId="34807"/>
         <pc:sldMkLst>
           <pc:docMk/>
           <pc:sldMk cId="728984326" sldId="2563"/>
         </pc:sldMkLst>
         <pc:spChg chg="mod">
-          <ac:chgData name="Mukesh Kesharwani" userId="S::mkesharw@adobe.com::dd4ce3d9-e302-45d5-927d-ab066c339129" providerId="AD" clId="Web-{D2D4ACC2-162D-9CF6-58FF-A6039CA57F2D}" dt="2025-12-02T23:08:49.400" v="12" actId="20577"/>
+          <ac:chgData name="" userId="" providerId="" clId="Web-{77BE7CFD-D5EE-4162-867B-83413E8BA38D}" dt="2025-11-30T22:26:16.262" v="1" actId="34807"/>
+          <ac:spMkLst>
+            <pc:docMk/>
+            <pc:sldMk cId="728984326" sldId="2563"/>
+            <ac:spMk id="2" creationId="{81136E39-AA3A-344A-3B1B-3F20C5A7EE49}"/>
+          </ac:spMkLst>
+        </pc:spChg>
+        <pc:spChg chg="mod">
+          <ac:chgData name="" userId="" providerId="" clId="Web-{77BE7CFD-D5EE-4162-867B-83413E8BA38D}" dt="2025-11-30T22:26:16.262" v="1" actId="34807"/>
           <ac:spMkLst>
             <pc:docMk/>
             <pc:sldMk cId="728984326" sldId="2563"/>
             <ac:spMk id="4" creationId="{7A138BE7-90C6-0303-4EC0-86D7AC552D32}"/>
           </ac:spMkLst>
         </pc:spChg>
+        <pc:picChg chg="mod">
+          <ac:chgData name="" userId="" providerId="" clId="Web-{77BE7CFD-D5EE-4162-867B-83413E8BA38D}" dt="2025-11-30T22:26:16.262" v="1" actId="34807"/>
+          <ac:picMkLst>
+            <pc:docMk/>
+            <pc:sldMk cId="728984326" sldId="2563"/>
+            <ac:picMk id="5" creationId="{B643B872-4418-4744-8E25-A016FCB9312E}"/>
+          </ac:picMkLst>
+        </pc:picChg>
       </pc:sldChg>
-      <pc:sldChg chg="modSp">
-        <pc:chgData name="Mukesh Kesharwani" userId="S::mkesharw@adobe.com::dd4ce3d9-e302-45d5-927d-ab066c339129" providerId="AD" clId="Web-{D2D4ACC2-162D-9CF6-58FF-A6039CA57F2D}" dt="2025-12-02T23:10:12.792" v="28" actId="20577"/>
+      <pc:sldChg chg="modSp add mod modTransition addAnim chgLayout">
+        <pc:chgData name="" userId="" providerId="" clId="Web-{77BE7CFD-D5EE-4162-867B-83413E8BA38D}" dt="2025-11-30T22:26:16.262" v="7" actId="34807"/>
+        <pc:sldMkLst>
+          <pc:docMk/>
+          <pc:sldMk cId="747674798" sldId="2564"/>
+        </pc:sldMkLst>
+        <pc:spChg chg="mod">
+          <ac:chgData name="" userId="" providerId="" clId="Web-{77BE7CFD-D5EE-4162-867B-83413E8BA38D}" dt="2025-11-30T22:26:16.262" v="1" actId="34807"/>
+          <ac:spMkLst>
+            <pc:docMk/>
+            <pc:sldMk cId="747674798" sldId="2564"/>
+            <ac:spMk id="2" creationId="{0B25FC94-B622-F45A-7D57-48F7D08AEDB1}"/>
+          </ac:spMkLst>
+        </pc:spChg>
+      </pc:sldChg>
+      <pc:sldChg chg="modSp add mod modTransition modClrScheme addAnim chgLayout">
+        <pc:chgData name="" userId="" providerId="" clId="Web-{77BE7CFD-D5EE-4162-867B-83413E8BA38D}" dt="2025-11-30T22:26:16.262" v="8" actId="34807"/>
         <pc:sldMkLst>
           <pc:docMk/>
           <pc:sldMk cId="2742718792" sldId="2565"/>
         </pc:sldMkLst>
         <pc:spChg chg="mod">
-          <ac:chgData name="Mukesh Kesharwani" userId="S::mkesharw@adobe.com::dd4ce3d9-e302-45d5-927d-ab066c339129" providerId="AD" clId="Web-{D2D4ACC2-162D-9CF6-58FF-A6039CA57F2D}" dt="2025-12-02T23:09:00.603" v="13" actId="14100"/>
+          <ac:chgData name="" userId="" providerId="" clId="Web-{77BE7CFD-D5EE-4162-867B-83413E8BA38D}" dt="2025-11-30T22:26:16.262" v="1" actId="34807"/>
           <ac:spMkLst>
             <pc:docMk/>
             <pc:sldMk cId="2742718792" sldId="2565"/>
@@ -1025,95 +892,225 @@
           </ac:spMkLst>
         </pc:spChg>
         <pc:spChg chg="mod">
-          <ac:chgData name="Mukesh Kesharwani" userId="S::mkesharw@adobe.com::dd4ce3d9-e302-45d5-927d-ab066c339129" providerId="AD" clId="Web-{D2D4ACC2-162D-9CF6-58FF-A6039CA57F2D}" dt="2025-12-02T23:10:12.792" v="28" actId="20577"/>
+          <ac:chgData name="" userId="" providerId="" clId="Web-{77BE7CFD-D5EE-4162-867B-83413E8BA38D}" dt="2025-11-30T22:26:16.262" v="1" actId="34807"/>
           <ac:spMkLst>
             <pc:docMk/>
             <pc:sldMk cId="2742718792" sldId="2565"/>
             <ac:spMk id="4" creationId="{197970EA-EBDC-976C-C7C1-986F1E12053D}"/>
           </ac:spMkLst>
         </pc:spChg>
+        <pc:picChg chg="mod">
+          <ac:chgData name="" userId="" providerId="" clId="Web-{77BE7CFD-D5EE-4162-867B-83413E8BA38D}" dt="2025-11-30T22:26:16.262" v="1" actId="34807"/>
+          <ac:picMkLst>
+            <pc:docMk/>
+            <pc:sldMk cId="2742718792" sldId="2565"/>
+            <ac:picMk id="5" creationId="{F3F6CAF3-0383-4E86-9205-F349FEFC003B}"/>
+          </ac:picMkLst>
+        </pc:picChg>
       </pc:sldChg>
-      <pc:sldChg chg="ord">
-        <pc:chgData name="Mukesh Kesharwani" userId="S::mkesharw@adobe.com::dd4ce3d9-e302-45d5-927d-ab066c339129" providerId="AD" clId="Web-{D2D4ACC2-162D-9CF6-58FF-A6039CA57F2D}" dt="2025-12-02T23:13:55.847" v="37"/>
+      <pc:sldChg chg="modSp add mod modTransition addAnim chgLayout">
+        <pc:chgData name="" userId="" providerId="" clId="Web-{77BE7CFD-D5EE-4162-867B-83413E8BA38D}" dt="2025-11-30T22:26:16.262" v="9" actId="34807"/>
         <pc:sldMkLst>
           <pc:docMk/>
-          <pc:sldMk cId="3337152857" sldId="2577"/>
-        </pc:sldMkLst>
-      </pc:sldChg>
-      <pc:sldChg chg="modSp">
-        <pc:chgData name="Mukesh Kesharwani" userId="S::mkesharw@adobe.com::dd4ce3d9-e302-45d5-927d-ab066c339129" providerId="AD" clId="Web-{D2D4ACC2-162D-9CF6-58FF-A6039CA57F2D}" dt="2025-12-02T23:12:45.440" v="35" actId="20577"/>
-        <pc:sldMkLst>
-          <pc:docMk/>
-          <pc:sldMk cId="2644275766" sldId="2578"/>
+          <pc:sldMk cId="476014375" sldId="2566"/>
         </pc:sldMkLst>
         <pc:spChg chg="mod">
-          <ac:chgData name="Mukesh Kesharwani" userId="S::mkesharw@adobe.com::dd4ce3d9-e302-45d5-927d-ab066c339129" providerId="AD" clId="Web-{D2D4ACC2-162D-9CF6-58FF-A6039CA57F2D}" dt="2025-12-02T23:12:45.440" v="35" actId="20577"/>
+          <ac:chgData name="" userId="" providerId="" clId="Web-{77BE7CFD-D5EE-4162-867B-83413E8BA38D}" dt="2025-11-30T22:26:16.262" v="1" actId="34807"/>
           <ac:spMkLst>
             <pc:docMk/>
-            <pc:sldMk cId="2644275766" sldId="2578"/>
-            <ac:spMk id="4" creationId="{8066E1C7-3B8E-723E-2516-F9CE89A4D703}"/>
+            <pc:sldMk cId="476014375" sldId="2566"/>
+            <ac:spMk id="2" creationId="{347AD309-6F4E-FEF4-32DE-2C8FB15E35EF}"/>
           </ac:spMkLst>
         </pc:spChg>
       </pc:sldChg>
-      <pc:sldChg chg="modSp add replId">
-        <pc:chgData name="Mukesh Kesharwani" userId="S::mkesharw@adobe.com::dd4ce3d9-e302-45d5-927d-ab066c339129" providerId="AD" clId="Web-{D2D4ACC2-162D-9CF6-58FF-A6039CA57F2D}" dt="2025-12-02T23:14:10.753" v="42" actId="20577"/>
+      <pc:sldChg chg="modSp add mod modTransition">
+        <pc:chgData name="" userId="" providerId="" clId="Web-{77BE7CFD-D5EE-4162-867B-83413E8BA38D}" dt="2025-11-30T22:26:16.262" v="1" actId="34807"/>
         <pc:sldMkLst>
           <pc:docMk/>
-          <pc:sldMk cId="873167342" sldId="2579"/>
+          <pc:sldMk cId="1084978174" sldId="2567"/>
         </pc:sldMkLst>
         <pc:spChg chg="mod">
-          <ac:chgData name="Mukesh Kesharwani" userId="S::mkesharw@adobe.com::dd4ce3d9-e302-45d5-927d-ab066c339129" providerId="AD" clId="Web-{D2D4ACC2-162D-9CF6-58FF-A6039CA57F2D}" dt="2025-12-02T23:14:10.753" v="42" actId="20577"/>
+          <ac:chgData name="" userId="" providerId="" clId="Web-{77BE7CFD-D5EE-4162-867B-83413E8BA38D}" dt="2025-11-30T22:26:16.262" v="1" actId="34807"/>
           <ac:spMkLst>
             <pc:docMk/>
-            <pc:sldMk cId="873167342" sldId="2579"/>
-            <ac:spMk id="2" creationId="{380DE5E1-6333-3351-3696-896CE3B41693}"/>
+            <pc:sldMk cId="1084978174" sldId="2567"/>
+            <ac:spMk id="2" creationId="{28194AC3-1708-1834-DB2A-966777B913D5}"/>
+          </ac:spMkLst>
+        </pc:spChg>
+        <pc:graphicFrameChg chg="mod modGraphic">
+          <ac:chgData name="" userId="" providerId="" clId="Web-{77BE7CFD-D5EE-4162-867B-83413E8BA38D}" dt="2025-11-30T22:26:16.262" v="1" actId="34807"/>
+          <ac:graphicFrameMkLst>
+            <pc:docMk/>
+            <pc:sldMk cId="1084978174" sldId="2567"/>
+            <ac:graphicFrameMk id="4" creationId="{C949BDD0-2D54-4182-A65F-F4805EB5294D}"/>
+          </ac:graphicFrameMkLst>
+        </pc:graphicFrameChg>
+      </pc:sldChg>
+      <pc:sldChg chg="modSp add mod modTransition addAnim chgLayout">
+        <pc:chgData name="" userId="" providerId="" clId="Web-{77BE7CFD-D5EE-4162-867B-83413E8BA38D}" dt="2025-11-30T22:26:16.262" v="10" actId="34807"/>
+        <pc:sldMkLst>
+          <pc:docMk/>
+          <pc:sldMk cId="4274179907" sldId="2568"/>
+        </pc:sldMkLst>
+        <pc:spChg chg="mod">
+          <ac:chgData name="" userId="" providerId="" clId="Web-{77BE7CFD-D5EE-4162-867B-83413E8BA38D}" dt="2025-11-30T22:26:16.262" v="1" actId="34807"/>
+          <ac:spMkLst>
+            <pc:docMk/>
+            <pc:sldMk cId="4274179907" sldId="2568"/>
+            <ac:spMk id="2" creationId="{B646F812-1C4D-EF58-F76D-611E324DF8AE}"/>
           </ac:spMkLst>
         </pc:spChg>
       </pc:sldChg>
-      <pc:sldChg chg="modSp add ord replId">
-        <pc:chgData name="Mukesh Kesharwani" userId="S::mkesharw@adobe.com::dd4ce3d9-e302-45d5-927d-ab066c339129" providerId="AD" clId="Web-{D2D4ACC2-162D-9CF6-58FF-A6039CA57F2D}" dt="2025-12-02T23:14:51.207" v="47"/>
+      <pc:sldChg chg="modSp add mod modTransition modClrScheme addAnim chgLayout">
+        <pc:chgData name="" userId="" providerId="" clId="Web-{77BE7CFD-D5EE-4162-867B-83413E8BA38D}" dt="2025-11-30T22:26:16.262" v="11" actId="34807"/>
         <pc:sldMkLst>
           <pc:docMk/>
-          <pc:sldMk cId="2106497024" sldId="2580"/>
+          <pc:sldMk cId="1833236901" sldId="2569"/>
         </pc:sldMkLst>
         <pc:spChg chg="mod">
-          <ac:chgData name="Mukesh Kesharwani" userId="S::mkesharw@adobe.com::dd4ce3d9-e302-45d5-927d-ab066c339129" providerId="AD" clId="Web-{D2D4ACC2-162D-9CF6-58FF-A6039CA57F2D}" dt="2025-12-02T23:14:47.222" v="46" actId="20577"/>
+          <ac:chgData name="" userId="" providerId="" clId="Web-{77BE7CFD-D5EE-4162-867B-83413E8BA38D}" dt="2025-11-30T22:26:16.262" v="1" actId="34807"/>
           <ac:spMkLst>
             <pc:docMk/>
-            <pc:sldMk cId="2106497024" sldId="2580"/>
-            <ac:spMk id="2" creationId="{7D5AEE16-D6F8-5BF8-320D-6C45C3AEA4FC}"/>
+            <pc:sldMk cId="1833236901" sldId="2569"/>
+            <ac:spMk id="2" creationId="{18E5A30A-8BA5-56E7-592F-9C62A3709905}"/>
+          </ac:spMkLst>
+        </pc:spChg>
+        <pc:spChg chg="mod">
+          <ac:chgData name="" userId="" providerId="" clId="Web-{77BE7CFD-D5EE-4162-867B-83413E8BA38D}" dt="2025-11-30T22:26:16.262" v="1" actId="34807"/>
+          <ac:spMkLst>
+            <pc:docMk/>
+            <pc:sldMk cId="1833236901" sldId="2569"/>
+            <ac:spMk id="4" creationId="{C7675901-15DD-5F59-DB51-2753AD77E345}"/>
+          </ac:spMkLst>
+        </pc:spChg>
+        <pc:picChg chg="mod ord">
+          <ac:chgData name="" userId="" providerId="" clId="Web-{77BE7CFD-D5EE-4162-867B-83413E8BA38D}" dt="2025-11-30T22:26:16.262" v="1" actId="34807"/>
+          <ac:picMkLst>
+            <pc:docMk/>
+            <pc:sldMk cId="1833236901" sldId="2569"/>
+            <ac:picMk id="5" creationId="{E6C90398-4E13-4C49-AF28-FB57E3201CA8}"/>
+          </ac:picMkLst>
+        </pc:picChg>
+      </pc:sldChg>
+      <pc:sldChg chg="modSp add mod modTransition addAnim chgLayout">
+        <pc:chgData name="" userId="" providerId="" clId="Web-{77BE7CFD-D5EE-4162-867B-83413E8BA38D}" dt="2025-11-30T22:26:16.262" v="12" actId="34807"/>
+        <pc:sldMkLst>
+          <pc:docMk/>
+          <pc:sldMk cId="801341816" sldId="2570"/>
+        </pc:sldMkLst>
+        <pc:spChg chg="mod">
+          <ac:chgData name="" userId="" providerId="" clId="Web-{77BE7CFD-D5EE-4162-867B-83413E8BA38D}" dt="2025-11-30T22:26:16.262" v="1" actId="34807"/>
+          <ac:spMkLst>
+            <pc:docMk/>
+            <pc:sldMk cId="801341816" sldId="2570"/>
+            <ac:spMk id="2" creationId="{C6F6DED7-4462-4CAE-C870-915B89A0701A}"/>
           </ac:spMkLst>
         </pc:spChg>
       </pc:sldChg>
-    </pc:docChg>
-  </pc:docChgLst>
-  <pc:docChgLst>
-    <pc:chgData name="Mukesh Kesharwani" userId="S::mkesharw@adobe.com::dd4ce3d9-e302-45d5-927d-ab066c339129" providerId="AD" clId="Web-{928B1824-6DD8-2986-7595-C67F9F792115}"/>
-    <pc:docChg chg="addSld modSld modSection">
-      <pc:chgData name="Mukesh Kesharwani" userId="S::mkesharw@adobe.com::dd4ce3d9-e302-45d5-927d-ab066c339129" providerId="AD" clId="Web-{928B1824-6DD8-2986-7595-C67F9F792115}" dt="2025-12-02T01:11:57.490" v="67" actId="20577"/>
-      <pc:docMkLst>
-        <pc:docMk/>
-      </pc:docMkLst>
-      <pc:sldChg chg="modSp add replId">
-        <pc:chgData name="Mukesh Kesharwani" userId="S::mkesharw@adobe.com::dd4ce3d9-e302-45d5-927d-ab066c339129" providerId="AD" clId="Web-{928B1824-6DD8-2986-7595-C67F9F792115}" dt="2025-12-02T01:11:57.490" v="67" actId="20577"/>
+      <pc:sldChg chg="modSp add mod modTransition modClrScheme addAnim chgLayout">
+        <pc:chgData name="" userId="" providerId="" clId="Web-{77BE7CFD-D5EE-4162-867B-83413E8BA38D}" dt="2025-11-30T22:26:16.262" v="13" actId="34807"/>
         <pc:sldMkLst>
           <pc:docMk/>
-          <pc:sldMk cId="2644275766" sldId="2578"/>
+          <pc:sldMk cId="1705617485" sldId="2571"/>
         </pc:sldMkLst>
         <pc:spChg chg="mod">
-          <ac:chgData name="Mukesh Kesharwani" userId="S::mkesharw@adobe.com::dd4ce3d9-e302-45d5-927d-ab066c339129" providerId="AD" clId="Web-{928B1824-6DD8-2986-7595-C67F9F792115}" dt="2025-12-02T01:11:57.490" v="67" actId="20577"/>
+          <ac:chgData name="" userId="" providerId="" clId="Web-{77BE7CFD-D5EE-4162-867B-83413E8BA38D}" dt="2025-11-30T22:26:16.262" v="1" actId="34807"/>
           <ac:spMkLst>
             <pc:docMk/>
-            <pc:sldMk cId="2644275766" sldId="2578"/>
-            <ac:spMk id="2" creationId="{D85CC109-0F12-1318-02B1-E151F4AEE424}"/>
+            <pc:sldMk cId="1705617485" sldId="2571"/>
+            <ac:spMk id="2" creationId="{4AC11438-E729-E035-7C9A-E8D48F6ABC1D}"/>
           </ac:spMkLst>
         </pc:spChg>
         <pc:spChg chg="mod">
-          <ac:chgData name="Mukesh Kesharwani" userId="S::mkesharw@adobe.com::dd4ce3d9-e302-45d5-927d-ab066c339129" providerId="AD" clId="Web-{928B1824-6DD8-2986-7595-C67F9F792115}" dt="2025-12-02T01:10:12.970" v="40" actId="20577"/>
+          <ac:chgData name="" userId="" providerId="" clId="Web-{77BE7CFD-D5EE-4162-867B-83413E8BA38D}" dt="2025-11-30T22:26:16.262" v="1" actId="34807"/>
           <ac:spMkLst>
             <pc:docMk/>
-            <pc:sldMk cId="2644275766" sldId="2578"/>
-            <ac:spMk id="4" creationId="{8066E1C7-3B8E-723E-2516-F9CE89A4D703}"/>
+            <pc:sldMk cId="1705617485" sldId="2571"/>
+            <ac:spMk id="4" creationId="{FF5F5206-0C29-02EF-C405-FF8B92D91801}"/>
+          </ac:spMkLst>
+        </pc:spChg>
+        <pc:picChg chg="mod ord">
+          <ac:chgData name="" userId="" providerId="" clId="Web-{77BE7CFD-D5EE-4162-867B-83413E8BA38D}" dt="2025-11-30T22:26:16.262" v="1" actId="34807"/>
+          <ac:picMkLst>
+            <pc:docMk/>
+            <pc:sldMk cId="1705617485" sldId="2571"/>
+            <ac:picMk id="5" creationId="{8A79CBC0-757D-4562-9747-1E7FC3BBD048}"/>
+          </ac:picMkLst>
+        </pc:picChg>
+      </pc:sldChg>
+      <pc:sldChg chg="modSp add mod modTransition addAnim chgLayout">
+        <pc:chgData name="" userId="" providerId="" clId="Web-{77BE7CFD-D5EE-4162-867B-83413E8BA38D}" dt="2025-11-30T22:26:16.262" v="14" actId="34807"/>
+        <pc:sldMkLst>
+          <pc:docMk/>
+          <pc:sldMk cId="1503440935" sldId="2572"/>
+        </pc:sldMkLst>
+        <pc:spChg chg="mod">
+          <ac:chgData name="" userId="" providerId="" clId="Web-{77BE7CFD-D5EE-4162-867B-83413E8BA38D}" dt="2025-11-30T22:26:16.262" v="1" actId="34807"/>
+          <ac:spMkLst>
+            <pc:docMk/>
+            <pc:sldMk cId="1503440935" sldId="2572"/>
+            <ac:spMk id="2" creationId="{1C43BC81-FAB3-4406-6CCE-46366DF437FA}"/>
+          </ac:spMkLst>
+        </pc:spChg>
+      </pc:sldChg>
+      <pc:sldChg chg="modSp add mod modTransition modClrScheme addAnim chgLayout">
+        <pc:chgData name="" userId="" providerId="" clId="Web-{77BE7CFD-D5EE-4162-867B-83413E8BA38D}" dt="2025-11-30T22:26:16.262" v="15" actId="34807"/>
+        <pc:sldMkLst>
+          <pc:docMk/>
+          <pc:sldMk cId="1420985552" sldId="2573"/>
+        </pc:sldMkLst>
+        <pc:spChg chg="mod">
+          <ac:chgData name="" userId="" providerId="" clId="Web-{77BE7CFD-D5EE-4162-867B-83413E8BA38D}" dt="2025-11-30T22:26:16.262" v="1" actId="34807"/>
+          <ac:spMkLst>
+            <pc:docMk/>
+            <pc:sldMk cId="1420985552" sldId="2573"/>
+            <ac:spMk id="2" creationId="{FC5F2222-C4F6-3C84-92E3-65ADA02A79A5}"/>
+          </ac:spMkLst>
+        </pc:spChg>
+        <pc:spChg chg="mod">
+          <ac:chgData name="" userId="" providerId="" clId="Web-{77BE7CFD-D5EE-4162-867B-83413E8BA38D}" dt="2025-11-30T22:26:16.262" v="1" actId="34807"/>
+          <ac:spMkLst>
+            <pc:docMk/>
+            <pc:sldMk cId="1420985552" sldId="2573"/>
+            <ac:spMk id="4" creationId="{04364905-3D06-E066-F88A-B8ED3F85D180}"/>
+          </ac:spMkLst>
+        </pc:spChg>
+      </pc:sldChg>
+      <pc:sldChg chg="modSp add mod modTransition addAnim chgLayout">
+        <pc:chgData name="" userId="" providerId="" clId="Web-{77BE7CFD-D5EE-4162-867B-83413E8BA38D}" dt="2025-11-30T22:26:16.262" v="16" actId="34807"/>
+        <pc:sldMkLst>
+          <pc:docMk/>
+          <pc:sldMk cId="2754576721" sldId="2574"/>
+        </pc:sldMkLst>
+        <pc:spChg chg="mod">
+          <ac:chgData name="" userId="" providerId="" clId="Web-{77BE7CFD-D5EE-4162-867B-83413E8BA38D}" dt="2025-11-30T22:26:16.262" v="1" actId="34807"/>
+          <ac:spMkLst>
+            <pc:docMk/>
+            <pc:sldMk cId="2754576721" sldId="2574"/>
+            <ac:spMk id="2" creationId="{9B3A995C-7916-B79C-C2BD-9271D067263C}"/>
+          </ac:spMkLst>
+        </pc:spChg>
+      </pc:sldChg>
+      <pc:sldChg chg="modSp add mod modTransition modClrScheme addAnim chgLayout">
+        <pc:chgData name="" userId="" providerId="" clId="Web-{77BE7CFD-D5EE-4162-867B-83413E8BA38D}" dt="2025-11-30T22:26:16.262" v="17" actId="34807"/>
+        <pc:sldMkLst>
+          <pc:docMk/>
+          <pc:sldMk cId="1233667441" sldId="2575"/>
+        </pc:sldMkLst>
+        <pc:spChg chg="mod">
+          <ac:chgData name="" userId="" providerId="" clId="Web-{77BE7CFD-D5EE-4162-867B-83413E8BA38D}" dt="2025-11-30T22:26:16.262" v="1" actId="34807"/>
+          <ac:spMkLst>
+            <pc:docMk/>
+            <pc:sldMk cId="1233667441" sldId="2575"/>
+            <ac:spMk id="2" creationId="{EE337F72-21FC-4FD3-B2F9-9535B41F4F13}"/>
+          </ac:spMkLst>
+        </pc:spChg>
+        <pc:spChg chg="mod">
+          <ac:chgData name="" userId="" providerId="" clId="Web-{77BE7CFD-D5EE-4162-867B-83413E8BA38D}" dt="2025-11-30T22:26:16.262" v="1" actId="34807"/>
+          <ac:spMkLst>
+            <pc:docMk/>
+            <pc:sldMk cId="1233667441" sldId="2575"/>
+            <ac:spMk id="4" creationId="{5FF62A10-FECF-775B-6CE7-45995242EAFE}"/>
           </ac:spMkLst>
         </pc:spChg>
       </pc:sldChg>
@@ -2004,27 +2001,27 @@
             </a:lnSpc>
           </a:pPr>
           <a:r>
-            <a:rPr lang="en-US" dirty="0" err="1"/>
+            <a:rPr lang="en-US" err="1"/>
             <a:t>TechGRC</a:t>
           </a:r>
           <a:r>
-            <a:rPr lang="en-US" dirty="0"/>
+            <a:rPr lang="en-US"/>
             <a:t> leverage </a:t>
           </a:r>
           <a:r>
-            <a:rPr lang="en-US" dirty="0" err="1"/>
+            <a:rPr lang="en-US" err="1"/>
             <a:t>Paramify</a:t>
           </a:r>
           <a:r>
-            <a:rPr lang="en-US" dirty="0"/>
+            <a:rPr lang="en-US"/>
             <a:t>; but </a:t>
           </a:r>
           <a:r>
-            <a:rPr lang="en-US" dirty="0" err="1"/>
+            <a:rPr lang="en-US" err="1"/>
             <a:t>Paramify</a:t>
           </a:r>
           <a:r>
-            <a:rPr lang="en-US" dirty="0"/>
+            <a:rPr lang="en-US"/>
             <a:t> supports only FedRAMP, limiting broader compliance coverage.</a:t>
           </a:r>
         </a:p>
@@ -2572,27 +2569,27 @@
             <a:buNone/>
           </a:pPr>
           <a:r>
-            <a:rPr lang="en-US" sz="1400" kern="1200" dirty="0" err="1"/>
+            <a:rPr lang="en-US" sz="1400" kern="1200" err="1"/>
             <a:t>TechGRC</a:t>
           </a:r>
           <a:r>
-            <a:rPr lang="en-US" sz="1400" kern="1200" dirty="0"/>
+            <a:rPr lang="en-US" sz="1400" kern="1200"/>
             <a:t> leverage </a:t>
           </a:r>
           <a:r>
-            <a:rPr lang="en-US" sz="1400" kern="1200" dirty="0" err="1"/>
+            <a:rPr lang="en-US" sz="1400" kern="1200" err="1"/>
             <a:t>Paramify</a:t>
           </a:r>
           <a:r>
-            <a:rPr lang="en-US" sz="1400" kern="1200" dirty="0"/>
+            <a:rPr lang="en-US" sz="1400" kern="1200"/>
             <a:t>; but </a:t>
           </a:r>
           <a:r>
-            <a:rPr lang="en-US" sz="1400" kern="1200" dirty="0" err="1"/>
+            <a:rPr lang="en-US" sz="1400" kern="1200" err="1"/>
             <a:t>Paramify</a:t>
           </a:r>
           <a:r>
-            <a:rPr lang="en-US" sz="1400" kern="1200" dirty="0"/>
+            <a:rPr lang="en-US" sz="1400" kern="1200"/>
             <a:t> supports only FedRAMP, limiting broader compliance coverage.</a:t>
           </a:r>
         </a:p>
@@ -4299,7 +4296,7 @@
           <a:p>
             <a:fld id="{F223FF85-4E34-4546-B772-76DFA4A6051B}" type="datetimeFigureOut">
               <a:rPr lang="en-US" smtClean="0"/>
-              <a:t>12/16/25</a:t>
+              <a:t>12/15/2025</a:t>
             </a:fld>
             <a:endParaRPr lang="en-US"/>
           </a:p>
@@ -4476,7 +4473,7 @@
           <a:p>
             <a:fld id="{1B5CC398-6116-4BD2-9FAD-9822FDA158BE}" type="datetimeFigureOut">
               <a:rPr lang="en-US" smtClean="0"/>
-              <a:t>12/16/25</a:t>
+              <a:t>12/15/2025</a:t>
             </a:fld>
             <a:endParaRPr lang="en-US"/>
           </a:p>
@@ -4788,7 +4785,7 @@
           <a:lstStyle/>
           <a:p>
             <a:r>
-              <a:rPr lang="en-US" dirty="0"/>
+              <a:rPr lang="en-US"/>
               <a:t>
 ---
 </a:t>
@@ -4964,15 +4961,15 @@
           <a:lstStyle/>
           <a:p>
             <a:r>
-              <a:rPr lang="en-US" dirty="0"/>
+              <a:rPr lang="en-US"/>
               <a:t>The primary challenges include limited support for compliance standards beyond FedRAMP, excessive manual effort in generating SSP and </a:t>
             </a:r>
             <a:r>
-              <a:rPr lang="en-US" dirty="0" err="1"/>
+              <a:rPr lang="en-US" err="1"/>
               <a:t>SoA</a:t>
             </a:r>
             <a:r>
-              <a:rPr lang="en-US" dirty="0"/>
+              <a:rPr lang="en-US"/>
               <a:t> documents, and lack of automation for ongoing compliance tracking. These issues result in inefficiencies, increased risk of human error, and difficulty scaling compliance processes for multiple SSA implementations across regions. Additionally, the absence of integrated tools for managing control documentation and assessments creates gaps in traceability and consistency. Addressing these challenges is critical to maintaining Adobe's leadership in regulatory compliance and ensuring timely delivery of secure solutions to customers.</a:t>
             </a:r>
           </a:p>
@@ -5077,64 +5074,64 @@
           <a:lstStyle/>
           <a:p>
             <a:r>
-              <a:rPr lang="en-AU" b="1" dirty="0"/>
+              <a:rPr lang="en-AU" b="1"/>
               <a:t>High manual effort</a:t>
             </a:r>
             <a:r>
-              <a:rPr lang="en-AU" dirty="0"/>
+              <a:rPr lang="en-AU"/>
               <a:t>: Updating ACSC ISM documentation requires ~100 person-days annually across multiple teams.</a:t>
             </a:r>
           </a:p>
           <a:p>
             <a:r>
-              <a:rPr lang="en-AU" b="1" dirty="0"/>
+              <a:rPr lang="en-AU" b="1"/>
               <a:t>Frequent regulatory changes</a:t>
             </a:r>
             <a:r>
-              <a:rPr lang="en-AU" dirty="0"/>
+              <a:rPr lang="en-AU"/>
               <a:t>: Quarterly updates from Australian Government agencies create constant workload pressure.</a:t>
             </a:r>
           </a:p>
           <a:p>
             <a:r>
-              <a:rPr lang="en-AU" b="1" dirty="0"/>
+              <a:rPr lang="en-AU" b="1"/>
               <a:t>Point-in-time assessments</a:t>
             </a:r>
             <a:r>
-              <a:rPr lang="en-AU" dirty="0"/>
+              <a:rPr lang="en-AU"/>
               <a:t>: Current approach focuses on snapshot compliance rather than continuous assurance.</a:t>
             </a:r>
           </a:p>
           <a:p>
             <a:r>
-              <a:rPr lang="en-AU" b="1" dirty="0"/>
+              <a:rPr lang="en-AU" b="1"/>
               <a:t>Limited transparency</a:t>
             </a:r>
             <a:r>
-              <a:rPr lang="en-AU" dirty="0"/>
+              <a:rPr lang="en-AU"/>
               <a:t>: Manual processes make it hard to track changes and demonstrate compliance effectively.</a:t>
             </a:r>
           </a:p>
           <a:p>
             <a:r>
-              <a:rPr lang="en-AU" b="1" dirty="0"/>
+              <a:rPr lang="en-AU" b="1"/>
               <a:t>Risk of inaccuracies</a:t>
             </a:r>
             <a:r>
-              <a:rPr lang="en-AU" dirty="0"/>
+              <a:rPr lang="en-AU"/>
               <a:t>: Manual documentation increases chances of errors and inconsistencies.</a:t>
             </a:r>
           </a:p>
           <a:p>
             <a:r>
-              <a:rPr lang="en-AU" b="1" dirty="0"/>
+              <a:rPr lang="en-AU" b="1"/>
               <a:t>Resource drain</a:t>
             </a:r>
             <a:r>
-              <a:rPr lang="en-AU" dirty="0"/>
+              <a:rPr lang="en-AU"/>
               <a:t>: Skilled staff spend significant time on repetitive documentation instead of higher-value tasks.</a:t>
             </a:r>
-            <a:endParaRPr lang="en-US" dirty="0"/>
+            <a:endParaRPr lang="en-US"/>
           </a:p>
         </p:txBody>
       </p:sp>
@@ -5225,31 +5222,31 @@
           <a:lstStyle/>
           <a:p>
             <a:r>
-              <a:rPr lang="en-US" dirty="0"/>
+              <a:rPr lang="en-US"/>
               <a:t>This slide references information from the following file: https://</a:t>
             </a:r>
             <a:r>
-              <a:rPr lang="en-US" dirty="0" err="1"/>
+              <a:rPr lang="en-US" err="1"/>
               <a:t>securityboulevard.com</a:t>
             </a:r>
             <a:r>
-              <a:rPr lang="en-US" dirty="0"/>
+              <a:rPr lang="en-US"/>
               <a:t>/2024/12/leveraging-nist-oscal-to-provide-compliance-automation-the-complete-guide/,https://</a:t>
             </a:r>
             <a:r>
-              <a:rPr lang="en-US" dirty="0" err="1"/>
+              <a:rPr lang="en-US" err="1"/>
               <a:t>www.ignyteplatform.com</a:t>
             </a:r>
             <a:r>
-              <a:rPr lang="en-US" dirty="0"/>
+              <a:rPr lang="en-US"/>
               <a:t>/blog/compliance/what-</a:t>
             </a:r>
             <a:r>
-              <a:rPr lang="en-US" dirty="0" err="1"/>
+              <a:rPr lang="en-US" err="1"/>
               <a:t>oscal</a:t>
             </a:r>
             <a:r>
-              <a:rPr lang="en-US" dirty="0"/>
+              <a:rPr lang="en-US"/>
               <a:t>-why-matter/
 Opportunities with OSCAL Adoption
 </a:t>
@@ -5338,40 +5335,40 @@
           <a:lstStyle/>
           <a:p>
             <a:r>
-              <a:rPr lang="en-US" dirty="0"/>
+              <a:rPr lang="en-US"/>
               <a:t>This slide references information from the following file: https://</a:t>
             </a:r>
             <a:r>
-              <a:rPr lang="en-US" dirty="0" err="1"/>
+              <a:rPr lang="en-US" err="1"/>
               <a:t>securityboulevard.com</a:t>
             </a:r>
             <a:r>
-              <a:rPr lang="en-US" dirty="0"/>
+              <a:rPr lang="en-US"/>
               <a:t>/2024/12/leveraging-nist-oscal-to-provide-compliance-automation-the-complete-guide/,https://</a:t>
             </a:r>
             <a:r>
-              <a:rPr lang="en-US" dirty="0" err="1"/>
+              <a:rPr lang="en-US" err="1"/>
               <a:t>www.ignyteplatform.com</a:t>
             </a:r>
             <a:r>
-              <a:rPr lang="en-US" dirty="0"/>
+              <a:rPr lang="en-US"/>
               <a:t>/blog/compliance/what-</a:t>
             </a:r>
             <a:r>
-              <a:rPr lang="en-US" dirty="0" err="1"/>
+              <a:rPr lang="en-US" err="1"/>
               <a:t>oscal</a:t>
             </a:r>
             <a:r>
-              <a:rPr lang="en-US" dirty="0"/>
+              <a:rPr lang="en-US"/>
               <a:t>-why-matter/
 Adopting OSCAL offers significant benefits, including automation of SSP and </a:t>
             </a:r>
             <a:r>
-              <a:rPr lang="en-US" dirty="0" err="1"/>
+              <a:rPr lang="en-US" err="1"/>
               <a:t>SoA</a:t>
             </a:r>
             <a:r>
-              <a:rPr lang="en-US" dirty="0"/>
+              <a:rPr lang="en-US"/>
               <a:t> generation, continuous compliance tracking, and improved accuracy in documentation. It reduces operational overhead by eliminating manual processes and enables faster, higher-quality assessments. The tool prototype developed internally demonstrates potential for integration into Adobe's compliance workflows and could also contribute to the open-source community, enhancing industry-wide adoption. Future enhancements may include support for multiple standards, integration with existing governance tools, and advanced features for real-time compliance monitoring. These capabilities will position Adobe as a leader in compliance automation and strengthen its ability to meet global regulatory requirements efficiently.
 </a:t>
             </a:r>
@@ -5459,31 +5456,31 @@
           <a:lstStyle/>
           <a:p>
             <a:r>
-              <a:rPr lang="en-US" dirty="0"/>
+              <a:rPr lang="en-US"/>
               <a:t>This slide references information from the following file: https://</a:t>
             </a:r>
             <a:r>
-              <a:rPr lang="en-US" dirty="0" err="1"/>
+              <a:rPr lang="en-US" err="1"/>
               <a:t>pages.nist.gov</a:t>
             </a:r>
             <a:r>
-              <a:rPr lang="en-US" dirty="0"/>
+              <a:rPr lang="en-US"/>
               <a:t>/OSCAL/contribute/roadmap/,https://</a:t>
             </a:r>
             <a:r>
-              <a:rPr lang="en-US" dirty="0" err="1"/>
+              <a:rPr lang="en-US" err="1"/>
               <a:t>www.nist.gov</a:t>
             </a:r>
             <a:r>
-              <a:rPr lang="en-US" dirty="0"/>
+              <a:rPr lang="en-US"/>
               <a:t>/document/presentation-what-</a:t>
             </a:r>
             <a:r>
-              <a:rPr lang="en-US" dirty="0" err="1"/>
+              <a:rPr lang="en-US" err="1"/>
               <a:t>oscal</a:t>
             </a:r>
             <a:r>
-              <a:rPr lang="en-US" dirty="0"/>
+              <a:rPr lang="en-US"/>
               <a:t>-and-who-needs-it
 Strategic Importance for Adobe
 </a:t>
@@ -5572,40 +5569,40 @@
           <a:lstStyle/>
           <a:p>
             <a:r>
-              <a:rPr lang="en-US" dirty="0"/>
+              <a:rPr lang="en-US"/>
               <a:t>This slide references information from the following file: https://</a:t>
             </a:r>
             <a:r>
-              <a:rPr lang="en-US" dirty="0" err="1"/>
+              <a:rPr lang="en-US" err="1"/>
               <a:t>pages.nist.gov</a:t>
             </a:r>
             <a:r>
-              <a:rPr lang="en-US" dirty="0"/>
+              <a:rPr lang="en-US"/>
               <a:t>/OSCAL/contribute/roadmap/,https://</a:t>
             </a:r>
             <a:r>
-              <a:rPr lang="en-US" dirty="0" err="1"/>
+              <a:rPr lang="en-US" err="1"/>
               <a:t>www.nist.gov</a:t>
             </a:r>
             <a:r>
-              <a:rPr lang="en-US" dirty="0"/>
+              <a:rPr lang="en-US"/>
               <a:t>/document/presentation-what-</a:t>
             </a:r>
             <a:r>
-              <a:rPr lang="en-US" dirty="0" err="1"/>
+              <a:rPr lang="en-US" err="1"/>
               <a:t>oscal</a:t>
             </a:r>
             <a:r>
-              <a:rPr lang="en-US" dirty="0"/>
+              <a:rPr lang="en-US"/>
               <a:t>-and-who-needs-it
 Investment in OSCAL-based solutions is crucial as regulatory bodies increasingly mandate OSCAL formats for compliance documentation. This trend is evident in frameworks like FedRAMP and Singapore IM8, which require SSP and </a:t>
             </a:r>
             <a:r>
-              <a:rPr lang="en-US" dirty="0" err="1"/>
+              <a:rPr lang="en-US" err="1"/>
               <a:t>SoA</a:t>
             </a:r>
             <a:r>
-              <a:rPr lang="en-US" dirty="0"/>
+              <a:rPr lang="en-US"/>
               <a:t> in OSCAL format. By adopting OSCAL, Adobe can ensure compliance with these standards, reduce audit timelines, and improve operational efficiency. Furthermore, it positions Adobe as an innovator in compliance automation, enhancing its reputation and competitive advantage. The ability to scale compliance processes globally while maintaining accuracy and transparency will support Adobe's strategic objectives and safeguard its multi-billion-dollar portfolio against regulatory risks.
 </a:t>
             </a:r>
@@ -5780,15 +5777,15 @@
           <a:lstStyle/>
           <a:p>
             <a:r>
-              <a:rPr lang="en-US" dirty="0"/>
+              <a:rPr lang="en-US"/>
               <a:t>The prototype tool can be explored at https://</a:t>
             </a:r>
             <a:r>
-              <a:rPr lang="en-US" dirty="0" err="1"/>
+              <a:rPr lang="en-US" err="1"/>
               <a:t>keekar.ddns.net</a:t>
             </a:r>
             <a:r>
-              <a:rPr lang="en-US" dirty="0"/>
+              <a:rPr lang="en-US"/>
               <a:t>/. It currently supports conversion of compliance data into OSCAL format and offers features for ongoing compliance tracking and control documentation management. Next steps include organizing a leadership review session to gather feedback, deciding on internal integration versus open-source contribution, and planning a roadmap for SSA compliance automation. This initiative will require collaboration across AMS leadership to align on priorities and resource allocation. The goal is to leverage this tool to enhance compliance efficiency, reduce operational risks, and support Adobe's global regulatory commitments.</a:t>
             </a:r>
           </a:p>
@@ -6091,40 +6088,40 @@
           <a:lstStyle/>
           <a:p>
             <a:r>
-              <a:rPr lang="en-US" dirty="0"/>
+              <a:rPr lang="en-US"/>
               <a:t>This slide references information from the following file: https://</a:t>
             </a:r>
             <a:r>
-              <a:rPr lang="en-US" dirty="0" err="1"/>
+              <a:rPr lang="en-US" err="1"/>
               <a:t>pages.nist.gov</a:t>
             </a:r>
             <a:r>
-              <a:rPr lang="en-US" dirty="0"/>
+              <a:rPr lang="en-US"/>
               <a:t>/OSCAL/contribute/roadmap/,https://</a:t>
             </a:r>
             <a:r>
-              <a:rPr lang="en-US" dirty="0" err="1"/>
+              <a:rPr lang="en-US" err="1"/>
               <a:t>www.nist.gov</a:t>
             </a:r>
             <a:r>
-              <a:rPr lang="en-US" dirty="0"/>
+              <a:rPr lang="en-US"/>
               <a:t>/document/presentation-what-</a:t>
             </a:r>
             <a:r>
-              <a:rPr lang="en-US" dirty="0" err="1"/>
+              <a:rPr lang="en-US" err="1"/>
               <a:t>oscal</a:t>
             </a:r>
             <a:r>
-              <a:rPr lang="en-US" dirty="0"/>
+              <a:rPr lang="en-US"/>
               <a:t>-and-who-needs-it
 Investment in OSCAL-based solutions is crucial as regulatory bodies increasingly mandate OSCAL formats for compliance documentation. This trend is evident in frameworks like FedRAMP and Singapore IM8, which require SSP and </a:t>
             </a:r>
             <a:r>
-              <a:rPr lang="en-US" dirty="0" err="1"/>
+              <a:rPr lang="en-US" err="1"/>
               <a:t>SoA</a:t>
             </a:r>
             <a:r>
-              <a:rPr lang="en-US" dirty="0"/>
+              <a:rPr lang="en-US"/>
               <a:t> in OSCAL format. By adopting OSCAL, Adobe can ensure compliance with these standards, reduce audit timelines, and improve operational efficiency. Furthermore, it positions Adobe as an innovator in compliance automation, enhancing its reputation and competitive advantage. The ability to scale compliance processes globally while maintaining accuracy and transparency will support Adobe's strategic objectives and safeguard its multi-billion-dollar portfolio against regulatory risks.
 </a:t>
             </a:r>
@@ -6440,7 +6437,7 @@
           <a:lstStyle/>
           <a:p>
             <a:r>
-              <a:rPr lang="en-US" dirty="0"/>
+              <a:rPr lang="en-US"/>
               <a:t>This session aims to introduce a prototype compliance tool developed to address the growing need for OSCAL (Open Security Controls Assessment Language) adoption in Adobe's SSA implementations. The tool was initially designed to convert Excel inputs into OSCAL outputs but has evolved into a comprehensive solution for compliance tracking and control documentation management. The purpose is to demonstrate its capabilities, explain the strategic importance of OSCAL, and seek leadership input on whether to integrate internally or contribute to the open-source community. This initiative aligns with Adobe's commitment to regulatory compliance and operational excellence, ensuring that SSA implementations across regions meet stringent standards efficiently and effectively.</a:t>
             </a:r>
           </a:p>
@@ -6527,7 +6524,7 @@
           <a:lstStyle/>
           <a:p>
             <a:r>
-              <a:rPr lang="en-US" dirty="0"/>
+              <a:rPr lang="en-US"/>
               <a:t>
 </a:t>
             </a:r>
@@ -6615,7 +6612,7 @@
           <a:lstStyle/>
           <a:p>
             <a:r>
-              <a:rPr lang="en-US" dirty="0"/>
+              <a:rPr lang="en-US"/>
               <a:t>
 </a:t>
             </a:r>
@@ -6721,47 +6718,47 @@
           <a:lstStyle/>
           <a:p>
             <a:r>
-              <a:rPr lang="en-US" dirty="0"/>
+              <a:rPr lang="en-US"/>
               <a:t>This slide references information from the following file: https://</a:t>
             </a:r>
             <a:r>
-              <a:rPr lang="en-US" dirty="0" err="1"/>
+              <a:rPr lang="en-US" err="1"/>
               <a:t>pages.nist.gov</a:t>
             </a:r>
             <a:r>
-              <a:rPr lang="en-US" dirty="0"/>
+              <a:rPr lang="en-US"/>
               <a:t>/OSCAL/,https://</a:t>
             </a:r>
             <a:r>
-              <a:rPr lang="en-US" dirty="0" err="1"/>
+              <a:rPr lang="en-US" err="1"/>
               <a:t>fedtechmagazine.com</a:t>
             </a:r>
             <a:r>
-              <a:rPr lang="en-US" dirty="0"/>
+              <a:rPr lang="en-US"/>
               <a:t>/article/2025/02/what-is-</a:t>
             </a:r>
             <a:r>
-              <a:rPr lang="en-US" dirty="0" err="1"/>
+              <a:rPr lang="en-US" err="1"/>
               <a:t>oscal</a:t>
             </a:r>
             <a:r>
-              <a:rPr lang="en-US" dirty="0"/>
+              <a:rPr lang="en-US"/>
               <a:t>-</a:t>
             </a:r>
             <a:r>
-              <a:rPr lang="en-US" dirty="0" err="1"/>
+              <a:rPr lang="en-US" err="1"/>
               <a:t>perfcon,https</a:t>
             </a:r>
             <a:r>
-              <a:rPr lang="en-US" dirty="0"/>
+              <a:rPr lang="en-US"/>
               <a:t>://</a:t>
             </a:r>
             <a:r>
-              <a:rPr lang="en-US" dirty="0" err="1"/>
+              <a:rPr lang="en-US" err="1"/>
               <a:t>securityboulevard.com</a:t>
             </a:r>
             <a:r>
-              <a:rPr lang="en-US" dirty="0"/>
+              <a:rPr lang="en-US"/>
               <a:t>/2024/12/leveraging-nist-oscal-to-provide-compliance-automation-the-complete-guide/
 What is OSCAL and Why It Matters
 </a:t>
@@ -6874,47 +6871,47 @@
           <a:lstStyle/>
           <a:p>
             <a:r>
-              <a:rPr lang="en-US" dirty="0"/>
+              <a:rPr lang="en-US"/>
               <a:t>This slide references information from the following file: https://</a:t>
             </a:r>
             <a:r>
-              <a:rPr lang="en-US" dirty="0" err="1"/>
+              <a:rPr lang="en-US" err="1"/>
               <a:t>pages.nist.gov</a:t>
             </a:r>
             <a:r>
-              <a:rPr lang="en-US" dirty="0"/>
+              <a:rPr lang="en-US"/>
               <a:t>/OSCAL/,https://</a:t>
             </a:r>
             <a:r>
-              <a:rPr lang="en-US" dirty="0" err="1"/>
+              <a:rPr lang="en-US" err="1"/>
               <a:t>fedtechmagazine.com</a:t>
             </a:r>
             <a:r>
-              <a:rPr lang="en-US" dirty="0"/>
+              <a:rPr lang="en-US"/>
               <a:t>/article/2025/02/what-is-</a:t>
             </a:r>
             <a:r>
-              <a:rPr lang="en-US" dirty="0" err="1"/>
+              <a:rPr lang="en-US" err="1"/>
               <a:t>oscal</a:t>
             </a:r>
             <a:r>
-              <a:rPr lang="en-US" dirty="0"/>
+              <a:rPr lang="en-US"/>
               <a:t>-</a:t>
             </a:r>
             <a:r>
-              <a:rPr lang="en-US" dirty="0" err="1"/>
+              <a:rPr lang="en-US" err="1"/>
               <a:t>perfcon,https</a:t>
             </a:r>
             <a:r>
-              <a:rPr lang="en-US" dirty="0"/>
+              <a:rPr lang="en-US"/>
               <a:t>://</a:t>
             </a:r>
             <a:r>
-              <a:rPr lang="en-US" dirty="0" err="1"/>
+              <a:rPr lang="en-US" err="1"/>
               <a:t>securityboulevard.com</a:t>
             </a:r>
             <a:r>
-              <a:rPr lang="en-US" dirty="0"/>
+              <a:rPr lang="en-US"/>
               <a:t>/2024/12/leveraging-nist-oscal-to-provide-compliance-automation-the-complete-guide/
 OSCAL, or Open Security Controls Assessment Language, is a NIST-led initiative designed to modernize and automate security and compliance processes. It provides machine-readable formats such as XML, JSON, and YAML to represent security controls and compliance data. This approach replaces traditional manual documentation methods, reducing audit durations from months to minutes, minimizing human error, and enabling automation. OSCAL supports interoperability across tools and frameworks, making compliance processes more efficient and scalable. Its adoption is driven by regulatory bodies like FedRAMP and is expected to become a global standard for compliance automation. By transitioning to OSCAL, organizations can streamline workflows, maintain up-to-date control information, and automate monitoring and assessment of system security posture. This positions Adobe to lead in compliance innovation and meet evolving regulatory requirements with agility.
 </a:t>
@@ -7096,31 +7093,31 @@
           <a:lstStyle/>
           <a:p>
             <a:r>
-              <a:rPr lang="en-US" dirty="0"/>
+              <a:rPr lang="en-US"/>
               <a:t>Adobe currently uses </a:t>
             </a:r>
             <a:r>
-              <a:rPr lang="en-US" dirty="0" err="1"/>
+              <a:rPr lang="en-US" err="1"/>
               <a:t>TechGRC</a:t>
             </a:r>
             <a:r>
-              <a:rPr lang="en-US" dirty="0"/>
+              <a:rPr lang="en-US"/>
               <a:t> for governance and risk management and has consulted </a:t>
             </a:r>
             <a:r>
-              <a:rPr lang="en-US" dirty="0" err="1"/>
+              <a:rPr lang="en-US" err="1"/>
               <a:t>Paramify</a:t>
             </a:r>
             <a:r>
-              <a:rPr lang="en-US" dirty="0"/>
+              <a:rPr lang="en-US"/>
               <a:t> for OSCAL support. However, </a:t>
             </a:r>
             <a:r>
-              <a:rPr lang="en-US" dirty="0" err="1"/>
+              <a:rPr lang="en-US" err="1"/>
               <a:t>Paramify's</a:t>
             </a:r>
             <a:r>
-              <a:rPr lang="en-US" dirty="0"/>
+              <a:rPr lang="en-US"/>
               <a:t> capabilities are limited to FedRAMP standards and do not extend to other frameworks. Compliance documentation processes largely rely on manual methods, such as spreadsheets and word processors, which are time-consuming and prone to errors. These limitations hinder scalability and efficiency, especially as SSA implementations expand globally. The lack of automation and multi-standard support creates operational overhead and delays in meeting regulatory requirements. This context underscores the need for a more robust, automated solution that can handle diverse compliance frameworks and streamline documentation processes.</a:t>
             </a:r>
           </a:p>
@@ -7405,7 +7402,7 @@
             <a:fld id="{4F1AC263-88EE-42CC-B640-B12BA856CF71}" type="datetime1">
               <a:rPr lang="en-US" smtClean="0"/>
               <a:pPr/>
-              <a:t>12/16/25</a:t>
+              <a:t>12/15/2025</a:t>
             </a:fld>
             <a:endParaRPr lang="en-US"/>
           </a:p>
@@ -8266,7 +8263,7 @@
             <a:fld id="{4F1AC263-88EE-42CC-B640-B12BA856CF71}" type="datetime1">
               <a:rPr lang="en-US" smtClean="0"/>
               <a:pPr/>
-              <a:t>12/16/25</a:t>
+              <a:t>12/15/2025</a:t>
             </a:fld>
             <a:endParaRPr lang="en-US"/>
           </a:p>
@@ -9227,7 +9224,7 @@
           <a:p>
             <a:fld id="{68A32F6A-E7E2-4607-B207-B787B539B854}" type="datetime1">
               <a:rPr lang="en-US" smtClean="0"/>
-              <a:t>12/16/25</a:t>
+              <a:t>12/15/2025</a:t>
             </a:fld>
             <a:endParaRPr lang="en-US"/>
           </a:p>
@@ -9999,7 +9996,7 @@
           <a:p>
             <a:fld id="{9467FC12-63BB-4A63-9424-BFBF8E1D71D9}" type="datetime1">
               <a:rPr lang="en-US" smtClean="0"/>
-              <a:t>12/16/25</a:t>
+              <a:t>12/15/2025</a:t>
             </a:fld>
             <a:endParaRPr lang="en-US"/>
           </a:p>
@@ -10777,7 +10774,7 @@
           <a:p>
             <a:fld id="{8BAA7FA5-AD20-4A92-9D35-3CC6CFA49E64}" type="datetime1">
               <a:rPr lang="en-US" smtClean="0"/>
-              <a:t>12/16/25</a:t>
+              <a:t>12/15/2025</a:t>
             </a:fld>
             <a:endParaRPr lang="en-US"/>
           </a:p>
@@ -11555,7 +11552,7 @@
           <a:p>
             <a:fld id="{802AB700-8552-46A0-B700-5DA0068ADBFC}" type="datetime1">
               <a:rPr lang="en-US" smtClean="0"/>
-              <a:t>12/16/25</a:t>
+              <a:t>12/15/2025</a:t>
             </a:fld>
             <a:endParaRPr lang="en-US"/>
           </a:p>
@@ -12333,7 +12330,7 @@
           <a:p>
             <a:fld id="{A892AD61-D199-4B74-B80B-2001400510FA}" type="datetime1">
               <a:rPr lang="en-US" smtClean="0"/>
-              <a:t>12/16/25</a:t>
+              <a:t>12/15/2025</a:t>
             </a:fld>
             <a:endParaRPr lang="en-US"/>
           </a:p>
@@ -13116,7 +13113,7 @@
           <a:p>
             <a:fld id="{D00D9374-B0AF-43C5-90A8-C409C7D54B55}" type="datetime1">
               <a:rPr lang="en-US" smtClean="0"/>
-              <a:t>12/16/25</a:t>
+              <a:t>12/15/2025</a:t>
             </a:fld>
             <a:endParaRPr lang="en-US"/>
           </a:p>
@@ -13982,7 +13979,7 @@
           <a:p>
             <a:fld id="{9CBB6888-43ED-4D3A-B8DA-89EF29644561}" type="datetime1">
               <a:rPr lang="en-US" smtClean="0"/>
-              <a:t>12/16/25</a:t>
+              <a:t>12/15/2025</a:t>
             </a:fld>
             <a:endParaRPr lang="en-US"/>
           </a:p>
@@ -14715,7 +14712,7 @@
           <a:p>
             <a:fld id="{27C7479B-2077-4468-85E0-F9294B46DEAE}" type="datetime1">
               <a:rPr lang="en-US" smtClean="0"/>
-              <a:t>12/16/25</a:t>
+              <a:t>12/15/2025</a:t>
             </a:fld>
             <a:endParaRPr lang="en-US"/>
           </a:p>
@@ -16150,7 +16147,7 @@
           <a:p>
             <a:fld id="{A7F72289-EB8A-47CA-A283-A769C9E761BF}" type="datetime1">
               <a:rPr lang="en-US" smtClean="0"/>
-              <a:t>12/16/25</a:t>
+              <a:t>12/15/2025</a:t>
             </a:fld>
             <a:endParaRPr lang="en-US"/>
           </a:p>
@@ -16362,7 +16359,7 @@
           <a:p>
             <a:fld id="{B42362D5-E350-46C5-8BB1-F9E806A91933}" type="datetime1">
               <a:rPr lang="en-US" smtClean="0"/>
-              <a:t>12/16/25</a:t>
+              <a:t>12/15/2025</a:t>
             </a:fld>
             <a:endParaRPr lang="en-US"/>
           </a:p>
@@ -16664,7 +16661,7 @@
           <a:p>
             <a:fld id="{A7F72289-EB8A-47CA-A283-A769C9E761BF}" type="datetime1">
               <a:rPr lang="en-US" smtClean="0"/>
-              <a:t>12/16/25</a:t>
+              <a:t>12/15/2025</a:t>
             </a:fld>
             <a:endParaRPr lang="en-US"/>
           </a:p>
@@ -18112,7 +18109,7 @@
           <a:p>
             <a:fld id="{74049900-C118-46F7-B9EF-5F7C1F0005B2}" type="datetime1">
               <a:rPr lang="en-US" smtClean="0"/>
-              <a:t>12/16/25</a:t>
+              <a:t>12/15/2025</a:t>
             </a:fld>
             <a:endParaRPr lang="en-US"/>
           </a:p>
@@ -18440,7 +18437,7 @@
           <a:p>
             <a:fld id="{74049900-C118-46F7-B9EF-5F7C1F0005B2}" type="datetime1">
               <a:rPr lang="en-US" smtClean="0"/>
-              <a:t>12/16/25</a:t>
+              <a:t>12/15/2025</a:t>
             </a:fld>
             <a:endParaRPr lang="en-US"/>
           </a:p>
@@ -19333,7 +19330,7 @@
           <a:p>
             <a:fld id="{0B4A3A31-ACEE-4A00-9ED7-D579651BDB0B}" type="datetime1">
               <a:rPr lang="en-US" smtClean="0"/>
-              <a:t>12/16/25</a:t>
+              <a:t>12/15/2025</a:t>
             </a:fld>
             <a:endParaRPr lang="en-US"/>
           </a:p>
@@ -20070,7 +20067,7 @@
           <a:p>
             <a:fld id="{0D1F969F-5863-4766-8113-71CA528EC836}" type="datetime1">
               <a:rPr lang="en-US" smtClean="0"/>
-              <a:t>12/16/25</a:t>
+              <a:t>12/15/2025</a:t>
             </a:fld>
             <a:endParaRPr lang="en-US"/>
           </a:p>
@@ -21517,7 +21514,7 @@
             <a:fld id="{FAD7B7F7-7F90-4F0B-A996-5443656EFF4A}" type="datetime1">
               <a:rPr lang="en-US" smtClean="0"/>
               <a:pPr/>
-              <a:t>12/16/25</a:t>
+              <a:t>12/15/2025</a:t>
             </a:fld>
             <a:endParaRPr lang="en-US"/>
           </a:p>
@@ -22326,7 +22323,7 @@
             <a:fld id="{FAD7B7F7-7F90-4F0B-A996-5443656EFF4A}" type="datetime1">
               <a:rPr lang="en-US" smtClean="0"/>
               <a:pPr/>
-              <a:t>12/16/25</a:t>
+              <a:t>12/15/2025</a:t>
             </a:fld>
             <a:endParaRPr lang="en-US"/>
           </a:p>
@@ -22737,7 +22734,7 @@
           <a:p>
             <a:fld id="{2086C921-50A5-4289-8B96-30101E64A548}" type="datetime1">
               <a:rPr lang="en-US" smtClean="0"/>
-              <a:t>12/16/25</a:t>
+              <a:t>12/15/2025</a:t>
             </a:fld>
             <a:endParaRPr lang="en-US"/>
           </a:p>
@@ -23102,7 +23099,7 @@
           <a:p>
             <a:fld id="{1B948B66-4D7B-4FF2-9F42-B85226272225}" type="datetime1">
               <a:rPr lang="en-US" smtClean="0"/>
-              <a:t>12/16/25</a:t>
+              <a:t>12/15/2025</a:t>
             </a:fld>
             <a:endParaRPr lang="en-US"/>
           </a:p>
@@ -23336,7 +23333,7 @@
           <a:p>
             <a:fld id="{6D1D18D0-7308-42C5-B784-8892F327ABD3}" type="datetime1">
               <a:rPr lang="en-US" smtClean="0"/>
-              <a:t>12/16/25</a:t>
+              <a:t>12/15/2025</a:t>
             </a:fld>
             <a:endParaRPr lang="en-US"/>
           </a:p>
@@ -24222,7 +24219,7 @@
           <a:p>
             <a:fld id="{9467FC12-63BB-4A63-9424-BFBF8E1D71D9}" type="datetime1">
               <a:rPr lang="en-US" smtClean="0"/>
-              <a:t>12/16/25</a:t>
+              <a:t>12/15/2025</a:t>
             </a:fld>
             <a:endParaRPr lang="en-US"/>
           </a:p>
@@ -24624,7 +24621,7 @@
           <a:p>
             <a:fld id="{F033B22D-4ADF-4F85-9D05-706FE7DF6EFA}" type="datetime1">
               <a:rPr lang="en-US" smtClean="0"/>
-              <a:t>12/16/25</a:t>
+              <a:t>12/15/2025</a:t>
             </a:fld>
             <a:endParaRPr lang="en-US"/>
           </a:p>
@@ -25465,7 +25462,7 @@
           <a:p>
             <a:fld id="{F033B22D-4ADF-4F85-9D05-706FE7DF6EFA}" type="datetime1">
               <a:rPr lang="en-US" smtClean="0"/>
-              <a:t>12/16/25</a:t>
+              <a:t>12/15/2025</a:t>
             </a:fld>
             <a:endParaRPr lang="en-US"/>
           </a:p>
@@ -26306,7 +26303,7 @@
           <a:p>
             <a:fld id="{3390AD02-C8DF-4FB3-89C8-8C8B1F633346}" type="datetime1">
               <a:rPr lang="en-US" smtClean="0"/>
-              <a:t>12/16/25</a:t>
+              <a:t>12/15/2025</a:t>
             </a:fld>
             <a:endParaRPr lang="en-US"/>
           </a:p>
@@ -27143,7 +27140,7 @@
           <a:p>
             <a:fld id="{3CC8FB4D-92F2-4C28-8BFC-2AE0229C3E9A}" type="datetime1">
               <a:rPr lang="en-US" smtClean="0"/>
-              <a:t>12/16/25</a:t>
+              <a:t>12/15/2025</a:t>
             </a:fld>
             <a:endParaRPr lang="en-US"/>
           </a:p>
@@ -27985,7 +27982,7 @@
           <a:p>
             <a:fld id="{7B708C30-1428-4C16-AD49-DE42CFEA37BF}" type="datetime1">
               <a:rPr lang="en-US" smtClean="0"/>
-              <a:t>12/16/25</a:t>
+              <a:t>12/15/2025</a:t>
             </a:fld>
             <a:endParaRPr lang="en-US"/>
           </a:p>
@@ -29197,7 +29194,7 @@
           <a:p>
             <a:fld id="{DCE8854E-90F8-4761-A9B8-18B1C5A3D25C}" type="datetime1">
               <a:rPr lang="en-US" smtClean="0"/>
-              <a:t>12/16/25</a:t>
+              <a:t>12/15/2025</a:t>
             </a:fld>
             <a:endParaRPr lang="en-US"/>
           </a:p>
@@ -29466,7 +29463,7 @@
             <a:fld id="{DCE8854E-90F8-4761-A9B8-18B1C5A3D25C}" type="datetime1">
               <a:rPr lang="en-US" smtClean="0"/>
               <a:pPr/>
-              <a:t>12/16/25</a:t>
+              <a:t>12/15/2025</a:t>
             </a:fld>
             <a:endParaRPr lang="en-US"/>
           </a:p>
@@ -29700,7 +29697,7 @@
           <a:p>
             <a:fld id="{1F35E9FA-D749-4B0D-A60E-CFC9630D3818}" type="datetime1">
               <a:rPr lang="en-US" smtClean="0"/>
-              <a:t>12/16/25</a:t>
+              <a:t>12/15/2025</a:t>
             </a:fld>
             <a:endParaRPr lang="en-US"/>
           </a:p>
@@ -29999,7 +29996,7 @@
             <a:fld id="{967A35BA-41D5-4E87-94C2-E365E2A3656B}" type="datetime1">
               <a:rPr lang="en-US" smtClean="0"/>
               <a:pPr/>
-              <a:t>12/16/25</a:t>
+              <a:t>12/15/2025</a:t>
             </a:fld>
             <a:endParaRPr lang="en-US"/>
           </a:p>
@@ -30852,7 +30849,7 @@
             <a:fld id="{AEFC801C-C54B-4E4E-A0DD-68C292C7D70F}" type="datetime1">
               <a:rPr lang="en-US" smtClean="0"/>
               <a:pPr/>
-              <a:t>12/16/25</a:t>
+              <a:t>12/15/2025</a:t>
             </a:fld>
             <a:endParaRPr lang="en-US"/>
           </a:p>
@@ -32115,7 +32112,7 @@
             <a:fld id="{D07A3B59-4DAC-4AFE-874D-3A86EC3801A0}" type="datetime1">
               <a:rPr lang="en-US" smtClean="0"/>
               <a:pPr/>
-              <a:t>12/16/25</a:t>
+              <a:t>12/15/2025</a:t>
             </a:fld>
             <a:endParaRPr lang="en-US"/>
           </a:p>
@@ -32380,7 +32377,7 @@
           <a:p>
             <a:fld id="{D615EEC7-2B19-40F0-9B64-A564E832ADEB}" type="datetime1">
               <a:rPr lang="en-US" smtClean="0"/>
-              <a:t>12/16/25</a:t>
+              <a:t>12/15/2025</a:t>
             </a:fld>
             <a:endParaRPr lang="en-US"/>
           </a:p>
@@ -33606,7 +33603,7 @@
           <a:p>
             <a:fld id="{4A6891D2-C712-4357-A4F9-7362E459A272}" type="datetime1">
               <a:rPr lang="en-US" smtClean="0"/>
-              <a:t>12/16/25</a:t>
+              <a:t>12/15/2025</a:t>
             </a:fld>
             <a:endParaRPr lang="en-US"/>
           </a:p>
@@ -33911,7 +33908,7 @@
             <a:fld id="{234566FD-24FB-4338-A35C-D9AE347B4F66}" type="datetime1">
               <a:rPr lang="en-US" smtClean="0"/>
               <a:pPr/>
-              <a:t>12/16/25</a:t>
+              <a:t>12/15/2025</a:t>
             </a:fld>
             <a:endParaRPr lang="en-US"/>
           </a:p>
@@ -34604,7 +34601,7 @@
           <a:p>
             <a:fld id="{D02BF1DD-1BF4-406D-9906-B4846BCC8D55}" type="datetime1">
               <a:rPr lang="en-US" smtClean="0"/>
-              <a:t>12/16/25</a:t>
+              <a:t>12/15/2025</a:t>
             </a:fld>
             <a:endParaRPr lang="en-US"/>
           </a:p>
@@ -35428,7 +35425,7 @@
           <a:p>
             <a:fld id="{2086C921-50A5-4289-8B96-30101E64A548}" type="datetime1">
               <a:rPr lang="en-US" smtClean="0"/>
-              <a:t>12/16/25</a:t>
+              <a:t>12/15/2025</a:t>
             </a:fld>
             <a:endParaRPr lang="en-US"/>
           </a:p>
@@ -35956,7 +35953,7 @@
           <a:p>
             <a:fld id="{2086C921-50A5-4289-8B96-30101E64A548}" type="datetime1">
               <a:rPr lang="en-US" smtClean="0"/>
-              <a:t>12/16/25</a:t>
+              <a:t>12/15/2025</a:t>
             </a:fld>
             <a:endParaRPr lang="en-US"/>
           </a:p>
@@ -36602,7 +36599,7 @@
           <a:p>
             <a:fld id="{2086C921-50A5-4289-8B96-30101E64A548}" type="datetime1">
               <a:rPr lang="en-US" smtClean="0"/>
-              <a:t>12/16/25</a:t>
+              <a:t>12/15/2025</a:t>
             </a:fld>
             <a:endParaRPr lang="en-US"/>
           </a:p>
@@ -36808,7 +36805,7 @@
           <a:p>
             <a:fld id="{18922BC5-E711-4A36-A80E-0A418F83672D}" type="datetime1">
               <a:rPr lang="en-US" smtClean="0"/>
-              <a:t>12/16/25</a:t>
+              <a:t>12/15/2025</a:t>
             </a:fld>
             <a:endParaRPr lang="en-US"/>
           </a:p>
@@ -37093,7 +37090,7 @@
           <a:p>
             <a:fld id="{81D94988-488B-40CC-9623-27A54F95F7B4}" type="datetime1">
               <a:rPr lang="en-US" smtClean="0"/>
-              <a:t>12/16/25</a:t>
+              <a:t>12/15/2025</a:t>
             </a:fld>
             <a:endParaRPr lang="en-US"/>
           </a:p>
@@ -37885,7 +37882,7 @@
           <a:p>
             <a:fld id="{FA3C7011-18F0-49E4-85C9-3E22BE44E3EB}" type="datetime1">
               <a:rPr lang="en-US" smtClean="0"/>
-              <a:t>12/16/25</a:t>
+              <a:t>12/15/2025</a:t>
             </a:fld>
             <a:endParaRPr lang="en-US"/>
           </a:p>
@@ -39133,7 +39130,7 @@
           <a:p>
             <a:fld id="{5888334B-5C34-4E7E-A4B0-3A19575F6DD8}" type="datetime1">
               <a:rPr lang="en-US" smtClean="0"/>
-              <a:t>12/16/25</a:t>
+              <a:t>12/15/2025</a:t>
             </a:fld>
             <a:endParaRPr lang="en-US"/>
           </a:p>
@@ -39444,7 +39441,7 @@
             <a:fld id="{1D3D1E3E-5DD4-4BAD-A138-1254BF94C224}" type="datetime1">
               <a:rPr lang="en-US" smtClean="0"/>
               <a:pPr/>
-              <a:t>12/16/25</a:t>
+              <a:t>12/15/2025</a:t>
             </a:fld>
             <a:endParaRPr lang="en-US"/>
           </a:p>
@@ -40376,7 +40373,7 @@
             <a:fld id="{1D3D1E3E-5DD4-4BAD-A138-1254BF94C224}" type="datetime1">
               <a:rPr lang="en-US" smtClean="0"/>
               <a:pPr/>
-              <a:t>12/16/25</a:t>
+              <a:t>12/15/2025</a:t>
             </a:fld>
             <a:endParaRPr lang="en-US"/>
           </a:p>
@@ -41164,7 +41161,7 @@
           <a:p>
             <a:fld id="{1F92EF8E-B9EB-49F8-83E1-F362FA442011}" type="datetime1">
               <a:rPr lang="en-US" smtClean="0"/>
-              <a:t>12/16/25</a:t>
+              <a:t>12/15/2025</a:t>
             </a:fld>
             <a:endParaRPr lang="en-US"/>
           </a:p>
@@ -42056,7 +42053,7 @@
             <a:fld id="{1F92EF8E-B9EB-49F8-83E1-F362FA442011}" type="datetime1">
               <a:rPr lang="en-US" smtClean="0"/>
               <a:pPr/>
-              <a:t>12/16/25</a:t>
+              <a:t>12/15/2025</a:t>
             </a:fld>
             <a:endParaRPr lang="en-US"/>
           </a:p>
@@ -42859,7 +42856,7 @@
             <a:fld id="{1F92EF8E-B9EB-49F8-83E1-F362FA442011}" type="datetime1">
               <a:rPr lang="en-US" smtClean="0"/>
               <a:pPr/>
-              <a:t>12/16/25</a:t>
+              <a:t>12/15/2025</a:t>
             </a:fld>
             <a:endParaRPr lang="en-US"/>
           </a:p>
@@ -43640,7 +43637,7 @@
             <a:fld id="{7DF4F7BB-A1DF-4BD2-8D5B-CA9EB40127CE}" type="datetime1">
               <a:rPr lang="en-US" smtClean="0"/>
               <a:pPr/>
-              <a:t>12/16/25</a:t>
+              <a:t>12/15/2025</a:t>
             </a:fld>
             <a:endParaRPr lang="en-US"/>
           </a:p>
@@ -44269,7 +44266,7 @@
             <a:fld id="{7DF4F7BB-A1DF-4BD2-8D5B-CA9EB40127CE}" type="datetime1">
               <a:rPr lang="en-US" smtClean="0"/>
               <a:pPr/>
-              <a:t>12/16/25</a:t>
+              <a:t>12/15/2025</a:t>
             </a:fld>
             <a:endParaRPr lang="en-US"/>
           </a:p>
@@ -44891,7 +44888,7 @@
           <a:lstStyle/>
           <a:p>
             <a:r>
-              <a:rPr lang="en-US" sz="3300" dirty="0"/>
+              <a:rPr lang="en-US" sz="3300"/>
               <a:t>OSCAL Compliance Tool – Executive Demo</a:t>
             </a:r>
           </a:p>
@@ -44926,7 +44923,7 @@
           <a:lstStyle/>
           <a:p>
             <a:r>
-              <a:rPr lang="en-US" dirty="0"/>
+              <a:rPr lang="en-US"/>
               <a:t>A comprehensive Overview of Compliance documents management (SSP/SOA/CCM)</a:t>
             </a:r>
           </a:p>
@@ -45201,7 +45198,7 @@
           <a:lstStyle/>
           <a:p>
             <a:r>
-              <a:rPr lang="en-US" sz="6800" dirty="0"/>
+              <a:rPr lang="en-US" sz="6800"/>
               <a:t>Challenges Faced</a:t>
             </a:r>
           </a:p>
@@ -45413,37 +45410,35 @@
               <a:buNone/>
             </a:pPr>
             <a:r>
-              <a:rPr lang="en-US" b="1" dirty="0"/>
+              <a:rPr lang="en-US" b="1"/>
               <a:t>Limited Compliance Support</a:t>
             </a:r>
           </a:p>
           <a:p>
             <a:pPr marL="0" lvl="1"/>
             <a:r>
-              <a:rPr dirty="0"/>
               <a:t>Current </a:t>
             </a:r>
             <a:r>
-              <a:rPr lang="en-AU" dirty="0"/>
+              <a:rPr lang="en-AU"/>
               <a:t>tools</a:t>
             </a:r>
             <a:r>
-              <a:rPr dirty="0"/>
               <a:t> lack support for compliance standards beyond FedRAMP, limiting scalability and adaptability.</a:t>
             </a:r>
             <a:r>
-              <a:rPr lang="en-AU" dirty="0"/>
+              <a:rPr lang="en-AU"/>
               <a:t> Growing requirements for OSCAL-compliant SSP and </a:t>
             </a:r>
             <a:r>
-              <a:rPr lang="en-AU" dirty="0" err="1"/>
+              <a:rPr lang="en-AU" err="1"/>
               <a:t>SoA</a:t>
             </a:r>
             <a:r>
-              <a:rPr lang="en-AU" dirty="0"/>
+              <a:rPr lang="en-AU"/>
               <a:t> documents reveal gaps. </a:t>
             </a:r>
-            <a:endParaRPr lang="en-US" dirty="0"/>
+            <a:endParaRPr lang="en-US"/>
           </a:p>
           <a:p>
             <a:pPr marL="0" indent="0">
@@ -45454,7 +45449,7 @@
               <a:buNone/>
             </a:pPr>
             <a:r>
-              <a:rPr lang="en-US" b="1" dirty="0"/>
+              <a:rPr lang="en-US" b="1"/>
               <a:t>Manual Document Generation</a:t>
             </a:r>
           </a:p>
@@ -45464,18 +45459,16 @@
               <a:buNone/>
             </a:pPr>
             <a:r>
-              <a:rPr dirty="0"/>
               <a:t>Excessive manual effort is required to generate SSP and </a:t>
             </a:r>
             <a:r>
-              <a:rPr dirty="0" err="1"/>
+              <a:rPr err="1"/>
               <a:t>SoA</a:t>
             </a:r>
             <a:r>
-              <a:rPr dirty="0"/>
               <a:t> documents, leading to inefficiency and errors.</a:t>
             </a:r>
-            <a:endParaRPr lang="en-US" dirty="0"/>
+            <a:endParaRPr lang="en-US"/>
           </a:p>
           <a:p>
             <a:pPr marL="0" indent="0">
@@ -45486,7 +45479,7 @@
               <a:buNone/>
             </a:pPr>
             <a:r>
-              <a:rPr lang="en-US" b="1" dirty="0"/>
+              <a:rPr lang="en-US" b="1"/>
               <a:t>Lack of Automation</a:t>
             </a:r>
           </a:p>
@@ -45496,10 +45489,9 @@
               <a:buNone/>
             </a:pPr>
             <a:r>
-              <a:rPr dirty="0"/>
               <a:t>Absence of automation for ongoing compliance tracking causes increased risk and difficulty in scaling.</a:t>
             </a:r>
-            <a:endParaRPr lang="en-US" dirty="0"/>
+            <a:endParaRPr lang="en-US"/>
           </a:p>
           <a:p>
             <a:pPr marL="0" indent="0">
@@ -45510,7 +45502,7 @@
               <a:buNone/>
             </a:pPr>
             <a:r>
-              <a:rPr lang="en-US" b="1" dirty="0"/>
+              <a:rPr lang="en-US" b="1"/>
               <a:t>Tool Integration Issues</a:t>
             </a:r>
           </a:p>
@@ -45520,33 +45512,32 @@
               <a:buNone/>
             </a:pPr>
             <a:r>
-              <a:rPr dirty="0"/>
               <a:t>Missing integrated tools for managing control documentation creates gaps in traceability and consistency.</a:t>
             </a:r>
-            <a:endParaRPr lang="en-AU" dirty="0"/>
+            <a:endParaRPr lang="en-AU"/>
           </a:p>
           <a:p>
             <a:pPr marL="0" lvl="1" indent="0">
               <a:buFont typeface="Arial" panose="020B0604020202020204" pitchFamily="34" charset="0"/>
               <a:buNone/>
             </a:pPr>
-            <a:endParaRPr lang="en-AU" dirty="0"/>
+            <a:endParaRPr lang="en-AU"/>
           </a:p>
           <a:p>
             <a:pPr fontAlgn="base"/>
             <a:r>
-              <a:rPr lang="en-US" b="1" dirty="0"/>
+              <a:rPr lang="en-US" b="1"/>
               <a:t>Transparency and Accuracy Issues</a:t>
             </a:r>
             <a:r>
-              <a:rPr lang="en-US" dirty="0"/>
+              <a:rPr lang="en-US"/>
               <a:t>​</a:t>
             </a:r>
           </a:p>
           <a:p>
             <a:pPr fontAlgn="base"/>
             <a:r>
-              <a:rPr lang="en-US" dirty="0"/>
+              <a:rPr lang="en-US"/>
               <a:t>Manual processes hinder tracking changes, version control, and increase risk of inaccuracies and audit findings.</a:t>
             </a:r>
           </a:p>
@@ -45555,7 +45546,7 @@
               <a:buFont typeface="Arial" panose="020B0604020202020204" pitchFamily="34" charset="0"/>
               <a:buNone/>
             </a:pPr>
-            <a:endParaRPr lang="en-US" dirty="0"/>
+            <a:endParaRPr lang="en-US"/>
           </a:p>
         </p:txBody>
       </p:sp>
@@ -45753,27 +45744,27 @@
           <a:lstStyle/>
           <a:p>
             <a:r>
-              <a:rPr lang="en-US" sz="3100" dirty="0"/>
+              <a:rPr lang="en-US" sz="3100"/>
               <a:t>Key Pain Points in Current Process </a:t>
             </a:r>
             <a:r>
-              <a:rPr lang="en-US" sz="2400" dirty="0"/>
+              <a:rPr lang="en-US" sz="2400"/>
               <a:t>(</a:t>
             </a:r>
             <a:r>
-              <a:rPr lang="en-US" sz="2400" dirty="0" err="1"/>
+              <a:rPr lang="en-US" sz="2400" err="1"/>
               <a:t>AEMGOvau</a:t>
             </a:r>
             <a:r>
-              <a:rPr lang="en-US" sz="2400" dirty="0"/>
+              <a:rPr lang="en-US" sz="2400"/>
               <a:t> </a:t>
             </a:r>
             <a:r>
-              <a:rPr lang="en-US" sz="2400" dirty="0" err="1"/>
+              <a:rPr lang="en-US" sz="2400" err="1"/>
               <a:t>Usecase</a:t>
             </a:r>
             <a:r>
-              <a:rPr lang="en-US" sz="2400" dirty="0"/>
+              <a:rPr lang="en-US" sz="2400"/>
               <a:t>) </a:t>
             </a:r>
           </a:p>
@@ -45823,14 +45814,13 @@
               </a:spcBef>
             </a:pPr>
             <a:r>
-              <a:rPr lang="en-US" b="1" dirty="0"/>
+              <a:rPr lang="en-US" b="1"/>
               <a:t>High Manual Effort</a:t>
             </a:r>
             <a:r>
-              <a:rPr lang="en-US" dirty="0"/>
+              <a:rPr lang="en-US"/>
               <a:t>​</a:t>
             </a:r>
-            <a:endParaRPr lang="en-US"/>
           </a:p>
           <a:p>
             <a:pPr fontAlgn="base">
@@ -45839,7 +45829,7 @@
               </a:spcBef>
             </a:pPr>
             <a:r>
-              <a:rPr lang="en-US" dirty="0"/>
+              <a:rPr lang="en-US"/>
               <a:t>Maintaining ACSC ISM documentation requires about 100 person-days annually, diverting skilled resources from strategic tasks.​</a:t>
             </a:r>
           </a:p>
@@ -45850,11 +45840,11 @@
               </a:spcBef>
             </a:pPr>
             <a:r>
-              <a:rPr lang="en-US" b="1" dirty="0"/>
+              <a:rPr lang="en-US" b="1"/>
               <a:t>Frequent Regulatory Changes</a:t>
             </a:r>
             <a:r>
-              <a:rPr lang="en-US" dirty="0"/>
+              <a:rPr lang="en-US"/>
               <a:t>​</a:t>
             </a:r>
           </a:p>
@@ -45865,7 +45855,7 @@
               </a:spcBef>
             </a:pPr>
             <a:r>
-              <a:rPr lang="en-US" dirty="0"/>
+              <a:rPr lang="en-US"/>
               <a:t>Quarterly updates introduce new controls, requiring constant interpretation and implementation effort.​</a:t>
             </a:r>
           </a:p>
@@ -45876,11 +45866,11 @@
               </a:spcBef>
             </a:pPr>
             <a:r>
-              <a:rPr lang="en-US" b="1" dirty="0"/>
+              <a:rPr lang="en-US" b="1"/>
               <a:t>Limited Continuous Assurance</a:t>
             </a:r>
             <a:r>
-              <a:rPr lang="en-US" dirty="0"/>
+              <a:rPr lang="en-US"/>
               <a:t>​</a:t>
             </a:r>
           </a:p>
@@ -45891,7 +45881,7 @@
               </a:spcBef>
             </a:pPr>
             <a:r>
-              <a:rPr lang="en-US" dirty="0"/>
+              <a:rPr lang="en-US"/>
               <a:t>Point-in-time compliance checks provide snapshots but limit proactive risk management and ongoing assurance.​</a:t>
             </a:r>
           </a:p>
@@ -45901,7 +45891,7 @@
                 <a:spcPts val="2500"/>
               </a:spcBef>
             </a:pPr>
-            <a:endParaRPr lang="en-US" b="1" dirty="0"/>
+            <a:endParaRPr lang="en-US" b="1"/>
           </a:p>
         </p:txBody>
       </p:sp>
@@ -46230,7 +46220,7 @@
                         <a:buNone/>
                       </a:pPr>
                       <a:r>
-                        <a:rPr lang="en-US" sz="1400" b="1" i="0" cap="all" dirty="0">
+                        <a:rPr lang="en-US" sz="1400" b="1" i="0" cap="all">
                           <a:solidFill>
                             <a:srgbClr val="131313"/>
                           </a:solidFill>
@@ -46240,7 +46230,7 @@
                         <a:t>Scenario</a:t>
                       </a:r>
                       <a:r>
-                        <a:rPr lang="en-US" sz="1400" b="1" i="0" dirty="0">
+                        <a:rPr lang="en-US" sz="1400" b="1" i="0">
                           <a:solidFill>
                             <a:srgbClr val="FFFFFF"/>
                           </a:solidFill>
@@ -46249,7 +46239,7 @@
                         </a:rPr>
                         <a:t>​</a:t>
                       </a:r>
-                      <a:endParaRPr lang="en-US" sz="1400" b="1" i="0" dirty="0">
+                      <a:endParaRPr lang="en-US" sz="1400" b="1" i="0">
                         <a:solidFill>
                           <a:srgbClr val="FFFFFF"/>
                         </a:solidFill>
@@ -46309,7 +46299,7 @@
                         <a:buNone/>
                       </a:pPr>
                       <a:r>
-                        <a:rPr lang="en-US" sz="1400" b="1" i="0" cap="all" dirty="0">
+                        <a:rPr lang="en-US" sz="1400" b="1" i="0" cap="all">
                           <a:solidFill>
                             <a:srgbClr val="131313"/>
                           </a:solidFill>
@@ -46319,7 +46309,7 @@
                         <a:t>Annual Effort (Person-Days)</a:t>
                       </a:r>
                       <a:r>
-                        <a:rPr lang="en-US" sz="1400" b="1" i="0" dirty="0">
+                        <a:rPr lang="en-US" sz="1400" b="1" i="0">
                           <a:solidFill>
                             <a:srgbClr val="FFFFFF"/>
                           </a:solidFill>
@@ -46328,7 +46318,7 @@
                         </a:rPr>
                         <a:t>​</a:t>
                       </a:r>
-                      <a:endParaRPr lang="en-US" sz="1400" b="1" i="0" dirty="0">
+                      <a:endParaRPr lang="en-US" sz="1400" b="1" i="0">
                         <a:solidFill>
                           <a:srgbClr val="FFFFFF"/>
                         </a:solidFill>
@@ -46388,7 +46378,7 @@
                         <a:buNone/>
                       </a:pPr>
                       <a:r>
-                        <a:rPr lang="en-US" sz="1400" b="1" i="0" cap="all" dirty="0">
+                        <a:rPr lang="en-US" sz="1400" b="1" i="0" cap="all">
                           <a:solidFill>
                             <a:srgbClr val="131313"/>
                           </a:solidFill>
@@ -46398,7 +46388,7 @@
                         <a:t>Annual Effort (Hours)</a:t>
                       </a:r>
                       <a:r>
-                        <a:rPr lang="en-US" sz="1400" b="1" i="0" dirty="0">
+                        <a:rPr lang="en-US" sz="1400" b="1" i="0">
                           <a:solidFill>
                             <a:srgbClr val="FFFFFF"/>
                           </a:solidFill>
@@ -46407,7 +46397,7 @@
                         </a:rPr>
                         <a:t>​</a:t>
                       </a:r>
-                      <a:endParaRPr lang="en-US" sz="1400" b="1" i="0" dirty="0">
+                      <a:endParaRPr lang="en-US" sz="1400" b="1" i="0">
                         <a:solidFill>
                           <a:srgbClr val="FFFFFF"/>
                         </a:solidFill>
@@ -46474,7 +46464,7 @@
                         <a:buNone/>
                       </a:pPr>
                       <a:r>
-                        <a:rPr lang="en-US" sz="1400" b="1" i="0" dirty="0">
+                        <a:rPr lang="en-US" sz="1400" b="1" i="0">
                           <a:solidFill>
                             <a:srgbClr val="131313"/>
                           </a:solidFill>
@@ -46484,7 +46474,7 @@
                         <a:t>Manual Process</a:t>
                       </a:r>
                       <a:r>
-                        <a:rPr lang="en-US" sz="1400" b="0" i="0" dirty="0">
+                        <a:rPr lang="en-US" sz="1400" b="0" i="0">
                           <a:solidFill>
                             <a:srgbClr val="131313"/>
                           </a:solidFill>
@@ -46493,7 +46483,7 @@
                         </a:rPr>
                         <a:t>​</a:t>
                       </a:r>
-                      <a:endParaRPr lang="en-US" sz="1400" b="0" i="0" dirty="0">
+                      <a:endParaRPr lang="en-US" sz="1400" b="0" i="0">
                         <a:solidFill>
                           <a:srgbClr val="131313"/>
                         </a:solidFill>
@@ -46553,7 +46543,7 @@
                         <a:buNone/>
                       </a:pPr>
                       <a:r>
-                        <a:rPr lang="en-US" sz="1400" b="0" i="0" dirty="0">
+                        <a:rPr lang="en-US" sz="1400" b="0" i="0">
                           <a:solidFill>
                             <a:srgbClr val="131313"/>
                           </a:solidFill>
@@ -46562,7 +46552,7 @@
                         </a:rPr>
                         <a:t>100​</a:t>
                       </a:r>
-                      <a:endParaRPr lang="en-US" sz="1400" b="0" i="0" dirty="0">
+                      <a:endParaRPr lang="en-US" sz="1400" b="0" i="0">
                         <a:solidFill>
                           <a:srgbClr val="131313"/>
                         </a:solidFill>
@@ -46777,7 +46767,7 @@
                         <a:buNone/>
                       </a:pPr>
                       <a:r>
-                        <a:rPr lang="en-US" sz="1400" b="0" i="0" dirty="0">
+                        <a:rPr lang="en-US" sz="1400" b="0" i="0">
                           <a:solidFill>
                             <a:srgbClr val="131313"/>
                           </a:solidFill>
@@ -46786,7 +46776,7 @@
                         </a:rPr>
                         <a:t>40–50​</a:t>
                       </a:r>
-                      <a:endParaRPr lang="en-US" sz="1400" b="0" i="0" dirty="0">
+                      <a:endParaRPr lang="en-US" sz="1400" b="0" i="0">
                         <a:solidFill>
                           <a:srgbClr val="131313"/>
                         </a:solidFill>
@@ -47070,7 +47060,7 @@
                         <a:buNone/>
                       </a:pPr>
                       <a:r>
-                        <a:rPr lang="en-US" sz="1400" b="0" i="0" dirty="0">
+                        <a:rPr lang="en-US" sz="1400" b="0" i="0">
                           <a:solidFill>
                             <a:srgbClr val="131313"/>
                           </a:solidFill>
@@ -47079,7 +47069,7 @@
                         </a:rPr>
                         <a:t>~400–480​</a:t>
                       </a:r>
-                      <a:endParaRPr lang="en-US" sz="1400" b="0" i="0" dirty="0">
+                      <a:endParaRPr lang="en-US" sz="1400" b="0" i="0">
                         <a:solidFill>
                           <a:srgbClr val="131313"/>
                         </a:solidFill>
@@ -47327,7 +47317,7 @@
           <a:lstStyle/>
           <a:p>
             <a:r>
-              <a:rPr lang="en-US" sz="6800" dirty="0"/>
+              <a:rPr lang="en-US" sz="6800"/>
               <a:t>Future Scope and Benefits</a:t>
             </a:r>
           </a:p>
@@ -47487,7 +47477,7 @@
           <a:lstStyle/>
           <a:p>
             <a:r>
-              <a:rPr lang="en-US" sz="3100" dirty="0"/>
+              <a:rPr lang="en-US" sz="3100"/>
               <a:t>Opportunities with OSCAL Adoption</a:t>
             </a:r>
           </a:p>
@@ -47537,17 +47527,17 @@
               </a:spcBef>
             </a:pPr>
             <a:r>
-              <a:rPr lang="en-US" b="1" dirty="0"/>
+              <a:rPr lang="en-US" b="1"/>
               <a:t>Global OSCAL Adoption</a:t>
             </a:r>
           </a:p>
           <a:p>
             <a:pPr marL="0" lvl="1"/>
             <a:r>
-              <a:rPr lang="en-US" dirty="0"/>
+              <a:rPr lang="en-US"/>
               <a:t>OSCAL adoption is increasing worldwide with key regulatory bodies endorsing machine-readable compliance standards.</a:t>
             </a:r>
-            <a:endParaRPr lang="en-US" b="1" dirty="0"/>
+            <a:endParaRPr lang="en-US" b="1"/>
           </a:p>
           <a:p>
             <a:pPr marL="0" indent="0">
@@ -47558,25 +47548,25 @@
               <a:buNone/>
             </a:pPr>
             <a:r>
-              <a:rPr lang="en-US" b="1" dirty="0"/>
+              <a:rPr lang="en-US" b="1"/>
               <a:t>Automation and Accuracy</a:t>
             </a:r>
           </a:p>
           <a:p>
             <a:pPr marL="0" lvl="1"/>
             <a:r>
-              <a:rPr lang="en-AU" dirty="0"/>
+              <a:rPr lang="en-AU"/>
               <a:t>OSCAL automates SSP and </a:t>
             </a:r>
             <a:r>
-              <a:rPr lang="en-AU" dirty="0" err="1"/>
+              <a:rPr lang="en-AU" err="1"/>
               <a:t>SoA</a:t>
             </a:r>
             <a:r>
-              <a:rPr lang="en-AU" dirty="0"/>
+              <a:rPr lang="en-AU"/>
               <a:t> creation, enhances documentation accuracy, reduces manual effort, and improves transparency.</a:t>
             </a:r>
-            <a:endParaRPr lang="en-US" dirty="0"/>
+            <a:endParaRPr lang="en-US"/>
           </a:p>
           <a:p>
             <a:pPr marL="0" indent="0">
@@ -47587,7 +47577,7 @@
               <a:buNone/>
             </a:pPr>
             <a:r>
-              <a:rPr lang="en-US" b="1" dirty="0"/>
+              <a:rPr lang="en-US" b="1"/>
               <a:t>Continuous Compliance Tracking</a:t>
             </a:r>
           </a:p>
@@ -47597,10 +47587,9 @@
               <a:buNone/>
             </a:pPr>
             <a:r>
-              <a:rPr dirty="0"/>
               <a:t>Enables ongoing compliance monitoring for faster, higher-quality assessments and reduced operational overhead.</a:t>
             </a:r>
-            <a:endParaRPr lang="en-US" dirty="0"/>
+            <a:endParaRPr lang="en-US"/>
           </a:p>
           <a:p>
             <a:pPr marL="0" indent="0">
@@ -47611,7 +47600,7 @@
               <a:buNone/>
             </a:pPr>
             <a:r>
-              <a:rPr lang="en-US" b="1" dirty="0"/>
+              <a:rPr lang="en-US" b="1"/>
               <a:t>Integration and Future Enhancements</a:t>
             </a:r>
           </a:p>
@@ -47621,14 +47610,13 @@
               <a:buNone/>
             </a:pPr>
             <a:r>
-              <a:rPr dirty="0"/>
               <a:t>Prototype integration with existing workflows and planned support for multiple standards and governance tools</a:t>
             </a:r>
             <a:r>
-              <a:rPr lang="en-AU" dirty="0"/>
+              <a:rPr lang="en-AU"/>
               <a:t> along with dashboard for metrics collection. </a:t>
             </a:r>
-            <a:endParaRPr lang="en-US" dirty="0"/>
+            <a:endParaRPr lang="en-US"/>
           </a:p>
           <a:p>
             <a:pPr marL="0" indent="0">
@@ -47639,7 +47627,7 @@
               <a:buNone/>
             </a:pPr>
             <a:r>
-              <a:rPr lang="en-US" b="1" dirty="0"/>
+              <a:rPr lang="en-US" b="1"/>
               <a:t>Industry Leadership Potential</a:t>
             </a:r>
           </a:p>
@@ -47649,18 +47637,16 @@
               <a:buNone/>
             </a:pPr>
             <a:r>
-              <a:rPr dirty="0"/>
               <a:t>Adopting OSCAL </a:t>
             </a:r>
             <a:r>
-              <a:rPr i="1" dirty="0"/>
+              <a:rPr i="1"/>
               <a:t>positions Adobe as a leader in compliance automation </a:t>
             </a:r>
             <a:r>
-              <a:rPr dirty="0"/>
               <a:t>and global regulatory readiness.</a:t>
             </a:r>
-            <a:endParaRPr lang="en-US" dirty="0"/>
+            <a:endParaRPr lang="en-US"/>
           </a:p>
         </p:txBody>
       </p:sp>
@@ -47852,7 +47838,7 @@
           <a:lstStyle/>
           <a:p>
             <a:r>
-              <a:rPr lang="en-US" sz="6800" dirty="0"/>
+              <a:rPr lang="en-US" sz="6800"/>
               <a:t>Why Investment Matters</a:t>
             </a:r>
           </a:p>
@@ -48012,7 +47998,7 @@
           <a:lstStyle/>
           <a:p>
             <a:r>
-              <a:rPr lang="en-US" sz="3100" dirty="0"/>
+              <a:rPr lang="en-US" sz="3100"/>
               <a:t>Strategic Importance for Adobe</a:t>
             </a:r>
           </a:p>
@@ -48062,12 +48048,12 @@
               </a:spcBef>
             </a:pPr>
             <a:r>
-              <a:rPr lang="en-AU" sz="2000" b="1" dirty="0">
+              <a:rPr lang="en-AU" sz="2000" b="1">
                 <a:latin typeface="+mj-lt"/>
               </a:rPr>
               <a:t>Establishes Adobe as a trailblazer in compliance automation.</a:t>
             </a:r>
-            <a:endParaRPr lang="en-US" sz="2000" b="1" dirty="0">
+            <a:endParaRPr lang="en-US" sz="2000" b="1">
               <a:latin typeface="+mj-lt"/>
             </a:endParaRPr>
           </a:p>
@@ -48080,7 +48066,7 @@
               <a:buNone/>
             </a:pPr>
             <a:r>
-              <a:rPr lang="en-US" b="1" dirty="0"/>
+              <a:rPr lang="en-US" b="1"/>
               <a:t>Compliance with Regulations</a:t>
             </a:r>
           </a:p>
@@ -48090,18 +48076,16 @@
               <a:buNone/>
             </a:pPr>
             <a:r>
-              <a:rPr dirty="0"/>
               <a:t>Adopting OSCAL ensures Adobe meets regulatory mandates like FedRAMP</a:t>
             </a:r>
             <a:r>
-              <a:rPr lang="en-AU" dirty="0"/>
+              <a:rPr lang="en-AU"/>
               <a:t>, ACSC ISM, CCCS </a:t>
             </a:r>
             <a:r>
-              <a:rPr dirty="0"/>
               <a:t> and Singapore IM8 effectively and accurately.</a:t>
             </a:r>
-            <a:endParaRPr lang="en-US" dirty="0"/>
+            <a:endParaRPr lang="en-US"/>
           </a:p>
           <a:p>
             <a:pPr marL="0" indent="0">
@@ -48112,7 +48096,7 @@
               <a:buNone/>
             </a:pPr>
             <a:r>
-              <a:rPr lang="en-US" b="1" dirty="0"/>
+              <a:rPr lang="en-US" b="1"/>
               <a:t>Operational Efficiency</a:t>
             </a:r>
           </a:p>
@@ -48122,10 +48106,9 @@
               <a:buNone/>
             </a:pPr>
             <a:r>
-              <a:rPr dirty="0"/>
               <a:t>Using OSCAL reduces audit timelines and streamlines compliance processes, enhancing Adobe's operational efficiency.</a:t>
             </a:r>
-            <a:endParaRPr lang="en-US" dirty="0"/>
+            <a:endParaRPr lang="en-US"/>
           </a:p>
           <a:p>
             <a:pPr marL="0" indent="0">
@@ -48136,7 +48119,7 @@
               <a:buNone/>
             </a:pPr>
             <a:r>
-              <a:rPr lang="en-US" b="1" dirty="0"/>
+              <a:rPr lang="en-US" b="1"/>
               <a:t>Competitive Advantage</a:t>
             </a:r>
           </a:p>
@@ -48146,10 +48129,9 @@
               <a:buNone/>
             </a:pPr>
             <a:r>
-              <a:rPr dirty="0"/>
               <a:t>Integrating OSCAL positions Adobe as an innovator in compliance automation, boosting reputation and market position.</a:t>
             </a:r>
-            <a:endParaRPr lang="en-US" dirty="0"/>
+            <a:endParaRPr lang="en-US"/>
           </a:p>
           <a:p>
             <a:pPr marL="0" indent="0">
@@ -48160,7 +48142,7 @@
               <a:buNone/>
             </a:pPr>
             <a:r>
-              <a:rPr lang="en-US" b="1" dirty="0"/>
+              <a:rPr lang="en-US" b="1"/>
               <a:t>Scalable Global Compliance</a:t>
             </a:r>
           </a:p>
@@ -48170,10 +48152,9 @@
               <a:buNone/>
             </a:pPr>
             <a:r>
-              <a:rPr dirty="0"/>
               <a:t>OSCAL enables Adobe to scale compliance globally while maintaining accuracy and transparency across operations.</a:t>
             </a:r>
-            <a:endParaRPr lang="en-US" dirty="0"/>
+            <a:endParaRPr lang="en-US"/>
           </a:p>
         </p:txBody>
       </p:sp>
@@ -48367,7 +48348,7 @@
           <a:lstStyle/>
           <a:p>
             <a:r>
-              <a:rPr lang="en-US" sz="6800" dirty="0"/>
+              <a:rPr lang="en-US" sz="6800"/>
               <a:t>Demo and Next Steps</a:t>
             </a:r>
           </a:p>
@@ -48527,7 +48508,7 @@
           <a:lstStyle/>
           <a:p>
             <a:r>
-              <a:rPr lang="en-US" sz="3700" dirty="0"/>
+              <a:rPr lang="en-US" sz="3700"/>
               <a:t>Prototype Overview and Action Plan</a:t>
             </a:r>
           </a:p>
@@ -48577,17 +48558,17 @@
               </a:spcBef>
             </a:pPr>
             <a:r>
-              <a:rPr lang="en-US" b="1" dirty="0"/>
+              <a:rPr lang="en-US" b="1"/>
               <a:t>Prototype is available at </a:t>
             </a:r>
             <a:r>
-              <a:rPr lang="en-AU" dirty="0">
+              <a:rPr lang="en-AU">
                 <a:latin typeface="Arial"/>
                 <a:hlinkClick r:id="rId3"/>
               </a:rPr>
               <a:t>https://keekar.ddns.net</a:t>
             </a:r>
-            <a:endParaRPr lang="en-AU" dirty="0">
+            <a:endParaRPr lang="en-AU">
               <a:latin typeface="Arial"/>
             </a:endParaRPr>
           </a:p>
@@ -48600,7 +48581,7 @@
               <a:buNone/>
             </a:pPr>
             <a:r>
-              <a:rPr lang="en-US" b="1" dirty="0"/>
+              <a:rPr lang="en-US" b="1"/>
               <a:t>Prototype Tool Features</a:t>
             </a:r>
           </a:p>
@@ -48610,10 +48591,9 @@
               <a:buNone/>
             </a:pPr>
             <a:r>
-              <a:rPr dirty="0"/>
               <a:t>Supports conversion of compliance data into OSCAL format with tracking and documentation management features.</a:t>
             </a:r>
-            <a:endParaRPr lang="en-US" dirty="0"/>
+            <a:endParaRPr lang="en-US"/>
           </a:p>
           <a:p>
             <a:pPr marL="0" indent="0">
@@ -48624,21 +48604,20 @@
               <a:buNone/>
             </a:pPr>
             <a:r>
-              <a:rPr lang="en-US" b="1" dirty="0"/>
+              <a:rPr lang="en-US" b="1"/>
               <a:t>Leadership Inputs &amp; Decisions</a:t>
             </a:r>
           </a:p>
           <a:p>
             <a:pPr marL="0" lvl="1"/>
             <a:r>
-              <a:rPr dirty="0"/>
               <a:t>Plan leadership review, feedback gathering, integration decisions, and roadmap for SSA compliance automation.</a:t>
             </a:r>
             <a:r>
-              <a:rPr lang="en-AU" dirty="0"/>
+              <a:rPr lang="en-AU"/>
               <a:t> Your feedback will guide decisions on open-source contribution or internal adoption for SSA</a:t>
             </a:r>
-            <a:endParaRPr lang="en-US" dirty="0"/>
+            <a:endParaRPr lang="en-US"/>
           </a:p>
           <a:p>
             <a:pPr marL="0" indent="0">
@@ -48649,7 +48628,7 @@
               <a:buNone/>
             </a:pPr>
             <a:r>
-              <a:rPr lang="en-US" b="1" dirty="0"/>
+              <a:rPr lang="en-US" b="1"/>
               <a:t>Collaboration and Goals</a:t>
             </a:r>
           </a:p>
@@ -48659,10 +48638,9 @@
               <a:buNone/>
             </a:pPr>
             <a:r>
-              <a:rPr dirty="0"/>
               <a:t>Collaboration across leadership to align priorities and resources to enhance compliance efficiency and reduce risks.</a:t>
             </a:r>
-            <a:endParaRPr lang="en-AU" dirty="0"/>
+            <a:endParaRPr lang="en-AU"/>
           </a:p>
           <a:p>
             <a:pPr>
@@ -48671,14 +48649,14 @@
               </a:spcBef>
             </a:pPr>
             <a:r>
-              <a:rPr lang="en-US" b="1" dirty="0"/>
+              <a:rPr lang="en-US" b="1"/>
               <a:t>Strategic Alignment</a:t>
             </a:r>
           </a:p>
           <a:p>
             <a:pPr marL="0" lvl="1"/>
             <a:r>
-              <a:rPr lang="en-US" dirty="0"/>
+              <a:rPr lang="en-US"/>
               <a:t>Engagement ensures alignment with compliance roadmap and investment priorities.</a:t>
             </a:r>
           </a:p>
@@ -48687,7 +48665,7 @@
               <a:buFont typeface="Arial" panose="020B0604020202020204" pitchFamily="34" charset="0"/>
               <a:buNone/>
             </a:pPr>
-            <a:endParaRPr lang="en-US" dirty="0"/>
+            <a:endParaRPr lang="en-US"/>
           </a:p>
         </p:txBody>
       </p:sp>
@@ -48882,7 +48860,7 @@
           <a:lstStyle/>
           <a:p>
             <a:r>
-              <a:rPr lang="en-US" dirty="0"/>
+              <a:rPr lang="en-US"/>
               <a:t>Tool ARCHITECTURE</a:t>
             </a:r>
           </a:p>
@@ -49042,7 +49020,7 @@
           <a:lstStyle/>
           <a:p>
             <a:r>
-              <a:rPr lang="en-US" sz="5600" dirty="0"/>
+              <a:rPr lang="en-US" sz="5600"/>
               <a:t>Introduction</a:t>
             </a:r>
           </a:p>
@@ -49208,7 +49186,7 @@
           <a:lstStyle/>
           <a:p>
             <a:r>
-              <a:rPr lang="en-US" dirty="0"/>
+              <a:rPr lang="en-US"/>
               <a:t>SYSTEM DESIGN OVERVIEW</a:t>
             </a:r>
           </a:p>
@@ -49263,7 +49241,7 @@
               <a:buNone/>
             </a:pPr>
             <a:r>
-              <a:rPr lang="en-AU" sz="1300" b="1" dirty="0"/>
+              <a:rPr lang="en-AU" sz="1300" b="1"/>
               <a:t>Frontend Interface</a:t>
             </a:r>
           </a:p>
@@ -49275,7 +49253,7 @@
               <a:buNone/>
             </a:pPr>
             <a:r>
-              <a:rPr lang="en-AU" sz="1300" dirty="0"/>
+              <a:rPr lang="en-AU" sz="1300"/>
               <a:t>The React-based frontend offers an intuitive user interface for managing compliance workflows efficiently.</a:t>
             </a:r>
           </a:p>
@@ -49291,7 +49269,7 @@
               <a:buNone/>
             </a:pPr>
             <a:r>
-              <a:rPr lang="en-AU" sz="1300" b="1" dirty="0"/>
+              <a:rPr lang="en-AU" sz="1300" b="1"/>
               <a:t>Backend Services</a:t>
             </a:r>
           </a:p>
@@ -49303,15 +49281,15 @@
               <a:buNone/>
             </a:pPr>
             <a:r>
-              <a:rPr lang="en-AU" sz="1300" dirty="0"/>
+              <a:rPr lang="en-AU" sz="1300"/>
               <a:t>Node.js backend manages API endpoints for generating compliance documents like SSP, Statement of Applicability (</a:t>
             </a:r>
             <a:r>
-              <a:rPr lang="en-AU" sz="1300" dirty="0" err="1"/>
+              <a:rPr lang="en-AU" sz="1300" err="1"/>
               <a:t>SoA</a:t>
             </a:r>
             <a:r>
-              <a:rPr lang="en-AU" sz="1300" dirty="0"/>
+              <a:rPr lang="en-AU" sz="1300"/>
               <a:t>), and Cloud Control Matrix (CCM).</a:t>
             </a:r>
           </a:p>
@@ -49327,11 +49305,11 @@
               <a:buNone/>
             </a:pPr>
             <a:r>
-              <a:rPr lang="en-AU" sz="1300" b="1" dirty="0" err="1"/>
+              <a:rPr lang="en-AU" sz="1300" b="1" err="1"/>
               <a:t>Catalog</a:t>
             </a:r>
             <a:r>
-              <a:rPr lang="en-AU" sz="1300" b="1" dirty="0"/>
+              <a:rPr lang="en-AU" sz="1300" b="1"/>
               <a:t> Integration</a:t>
             </a:r>
           </a:p>
@@ -49343,7 +49321,7 @@
               <a:buNone/>
             </a:pPr>
             <a:r>
-              <a:rPr lang="en-AU" sz="1300" dirty="0"/>
+              <a:rPr lang="en-AU" sz="1300"/>
               <a:t>The system integrates with external OSCAL catalogues like NIST SP 800-53 and ACSC ISM for compliance data.</a:t>
             </a:r>
           </a:p>
@@ -49359,7 +49337,7 @@
               <a:buNone/>
             </a:pPr>
             <a:r>
-              <a:rPr lang="en-AU" sz="1300" b="1" dirty="0"/>
+              <a:rPr lang="en-AU" sz="1300" b="1"/>
               <a:t>Extensibility and Export</a:t>
             </a:r>
           </a:p>
@@ -49371,7 +49349,7 @@
               <a:buNone/>
             </a:pPr>
             <a:r>
-              <a:rPr lang="en-AU" sz="1300" dirty="0"/>
+              <a:rPr lang="en-AU" sz="1300"/>
               <a:t>Supports export in JSON, Excel, PDF formats and future enhancements including GRC integration and collaboration.</a:t>
             </a:r>
           </a:p>
@@ -49386,7 +49364,7 @@
               <a:buNone/>
             </a:pPr>
             <a:r>
-              <a:rPr lang="en-AU" sz="1300" b="1" dirty="0"/>
+              <a:rPr lang="en-AU" sz="1300" b="1"/>
               <a:t>Monitoring Integration</a:t>
             </a:r>
           </a:p>
@@ -49399,7 +49377,7 @@
               <a:buNone/>
             </a:pPr>
             <a:r>
-              <a:rPr lang="en-AU" sz="1300" dirty="0"/>
+              <a:rPr lang="en-AU" sz="1300"/>
               <a:t>Designed to leverage the existing APIs to fetch the real-time metrices for automated control monitoring and testing without storing credentials in tools. </a:t>
             </a:r>
           </a:p>
@@ -49768,7 +49746,6 @@
               <a:rPr lang="en-US"/>
               <a:t>Thankyou </a:t>
             </a:r>
-            <a:endParaRPr lang="en-US" dirty="0"/>
           </a:p>
         </p:txBody>
       </p:sp>
@@ -49926,7 +49903,7 @@
           <a:lstStyle/>
           <a:p>
             <a:r>
-              <a:rPr lang="en-US" sz="3800" dirty="0"/>
+              <a:rPr lang="en-US" sz="3800"/>
               <a:t>Purpose of the Session</a:t>
             </a:r>
           </a:p>
@@ -50010,35 +49987,35 @@
               </a:spcBef>
             </a:pPr>
             <a:r>
-              <a:rPr lang="en-US" b="1" dirty="0"/>
+              <a:rPr lang="en-US" b="1"/>
               <a:t>Purpose of OSCAL Tool</a:t>
             </a:r>
           </a:p>
           <a:p>
             <a:pPr marL="0" lvl="1"/>
             <a:r>
-              <a:rPr lang="en-US" dirty="0"/>
+              <a:rPr lang="en-US"/>
               <a:t>The OSCAL Compliance Tool addresses evolving demand and simplifies compliance processes bring efficiency via automation.</a:t>
             </a:r>
           </a:p>
           <a:p>
             <a:pPr marL="0" lvl="1"/>
-            <a:endParaRPr lang="en-US" b="1" dirty="0"/>
+            <a:endParaRPr lang="en-US" b="1"/>
           </a:p>
           <a:p>
             <a:pPr marL="0" lvl="1"/>
             <a:r>
-              <a:rPr lang="en-US" b="1" dirty="0"/>
+              <a:rPr lang="en-US" b="1"/>
               <a:t>Evolution of the Solution</a:t>
             </a:r>
           </a:p>
           <a:p>
             <a:pPr marL="0" lvl="1"/>
             <a:r>
-              <a:rPr lang="en-AU" dirty="0"/>
+              <a:rPr lang="en-AU"/>
               <a:t>Our solution evolved from a demand of SSP in OSCAL for Singapore IM8 Compliance. (Attempt from Excel to OSCAL Convertor to this state)</a:t>
             </a:r>
-            <a:endParaRPr lang="en-US" dirty="0"/>
+            <a:endParaRPr lang="en-US"/>
           </a:p>
           <a:p>
             <a:pPr marL="0" indent="0">
@@ -50049,7 +50026,7 @@
               <a:buNone/>
             </a:pPr>
             <a:r>
-              <a:rPr lang="en-US" b="1" dirty="0"/>
+              <a:rPr lang="en-US" b="1"/>
               <a:t>Prototype Compliance Tool</a:t>
             </a:r>
           </a:p>
@@ -50059,26 +50036,23 @@
               <a:buNone/>
             </a:pPr>
             <a:r>
-              <a:rPr dirty="0"/>
               <a:t>The tool </a:t>
             </a:r>
             <a:r>
-              <a:rPr lang="en-AU" dirty="0"/>
+              <a:rPr lang="en-AU"/>
               <a:t>takes OSCAL</a:t>
             </a:r>
             <a:r>
-              <a:rPr dirty="0"/>
               <a:t> inputs </a:t>
             </a:r>
             <a:r>
-              <a:rPr lang="en-AU" dirty="0"/>
+              <a:rPr lang="en-AU"/>
               <a:t>and generates </a:t>
             </a:r>
             <a:r>
-              <a:rPr dirty="0"/>
               <a:t>OSCAL outputs, evolving into a full compliance tracking solution.</a:t>
             </a:r>
-            <a:endParaRPr lang="en-US" dirty="0"/>
+            <a:endParaRPr lang="en-US"/>
           </a:p>
           <a:p>
             <a:pPr marL="0" indent="0">
@@ -50089,7 +50063,7 @@
               <a:buNone/>
             </a:pPr>
             <a:r>
-              <a:rPr lang="en-US" b="1" dirty="0"/>
+              <a:rPr lang="en-US" b="1"/>
               <a:t>Strategic Importance of OSCAL</a:t>
             </a:r>
           </a:p>
@@ -50099,10 +50073,9 @@
               <a:buNone/>
             </a:pPr>
             <a:r>
-              <a:rPr dirty="0"/>
               <a:t>OSCAL adoption enhances regulatory compliance and operational excellence in SSA implementations.</a:t>
             </a:r>
-            <a:endParaRPr lang="en-US" dirty="0"/>
+            <a:endParaRPr lang="en-US"/>
           </a:p>
           <a:p>
             <a:pPr marL="0" indent="0">
@@ -50113,7 +50086,7 @@
               <a:buNone/>
             </a:pPr>
             <a:r>
-              <a:rPr lang="en-US" b="1" dirty="0"/>
+              <a:rPr lang="en-US" b="1"/>
               <a:t>Leadership Engagement</a:t>
             </a:r>
           </a:p>
@@ -50123,26 +50096,20 @@
               <a:buNone/>
             </a:pPr>
             <a:r>
-              <a:rPr dirty="0"/>
               <a:t>Seeking input on internal integration versus open-source contribution to align with </a:t>
             </a:r>
             <a:r>
-              <a:rPr lang="en-AU" dirty="0"/>
-              <a:t>Adobe Managed </a:t>
-            </a:r>
-            <a:r>
               <a:rPr lang="en-AU"/>
-              <a:t>Services G</a:t>
-            </a:r>
-            <a:r>
-              <a:rPr dirty="0" err="1"/>
+              <a:t>Adobe Managed Services G</a:t>
+            </a:r>
+            <a:r>
+              <a:rPr err="1"/>
               <a:t>oals</a:t>
             </a:r>
             <a:r>
-              <a:rPr dirty="0"/>
               <a:t>.</a:t>
             </a:r>
-            <a:endParaRPr lang="en-US" dirty="0"/>
+            <a:endParaRPr lang="en-US"/>
           </a:p>
         </p:txBody>
       </p:sp>
@@ -50300,12 +50267,8 @@
           <a:lstStyle/>
           <a:p>
             <a:r>
-              <a:rPr lang="en-US" sz="6200" dirty="0"/>
-              <a:t>Story </a:t>
-            </a:r>
-            <a:r>
               <a:rPr lang="en-US" sz="6200"/>
-              <a:t>Time </a:t>
+              <a:t>Story Time </a:t>
             </a:r>
             <a:br>
               <a:rPr lang="en-US" sz="6200"/>
@@ -50315,10 +50278,10 @@
               <a:t>for</a:t>
             </a:r>
             <a:br>
-              <a:rPr lang="en-US" sz="6200" dirty="0"/>
+              <a:rPr lang="en-US" sz="6200"/>
             </a:br>
             <a:r>
-              <a:rPr lang="en-US" sz="6200" dirty="0"/>
+              <a:rPr lang="en-US" sz="6200"/>
               <a:t>Problem Statement</a:t>
             </a:r>
           </a:p>
@@ -50478,14 +50441,14 @@
           <a:lstStyle/>
           <a:p>
             <a:r>
-              <a:rPr lang="en-US" sz="3700" dirty="0"/>
+              <a:rPr lang="en-US" sz="3700"/>
               <a:t>What Problem</a:t>
             </a:r>
             <a:br>
-              <a:rPr lang="en-US" sz="3700" dirty="0"/>
+              <a:rPr lang="en-US" sz="3700"/>
             </a:br>
             <a:r>
-              <a:rPr lang="en-US" sz="3700" dirty="0"/>
+              <a:rPr lang="en-US" sz="3700"/>
               <a:t>We are solving</a:t>
             </a:r>
           </a:p>
@@ -50566,7 +50529,7 @@
               </a:spcBef>
             </a:pPr>
             <a:r>
-              <a:rPr lang="en-US" dirty="0"/>
+              <a:rPr lang="en-US"/>
               <a:t>Process what is showed in next 5mins must be repeated by all the consumers security risk management team to identify the risk and manage risk coming from solution.</a:t>
             </a:r>
           </a:p>
@@ -50579,7 +50542,7 @@
               <a:buAutoNum type="arabicPeriod"/>
             </a:pPr>
             <a:r>
-              <a:rPr lang="en-US" b="1" dirty="0"/>
+              <a:rPr lang="en-US" b="1"/>
               <a:t>At the inception or changes to the solution ( Major change from Third Party Tools/services or inhouse Components). </a:t>
             </a:r>
           </a:p>
@@ -50590,7 +50553,7 @@
               </a:spcBef>
             </a:pPr>
             <a:r>
-              <a:rPr lang="en-US" dirty="0">
+              <a:rPr lang="en-US">
                 <a:hlinkClick r:id="rId4">
                   <a:extLst>
                     <a:ext uri="{A12FA001-AC4F-418D-AE19-62706E023703}">
@@ -50602,46 +50565,46 @@
               <a:t>AEMGovAu-CCM/SSP/SOA</a:t>
             </a:r>
             <a:r>
-              <a:rPr lang="en-US" dirty="0"/>
+              <a:rPr lang="en-US"/>
               <a:t> ,</a:t>
             </a:r>
             <a:r>
-              <a:rPr lang="en-US" dirty="0">
+              <a:rPr lang="en-US">
                 <a:hlinkClick r:id="rId5"/>
               </a:rPr>
               <a:t> AWS – CCM/SSP/SOA</a:t>
             </a:r>
             <a:r>
-              <a:rPr lang="en-US" dirty="0"/>
+              <a:rPr lang="en-US"/>
               <a:t>, </a:t>
             </a:r>
             <a:r>
-              <a:rPr lang="en-US" dirty="0">
+              <a:rPr lang="en-US">
                 <a:hlinkClick r:id="rId6"/>
               </a:rPr>
               <a:t>SPLUK IRAP Report</a:t>
             </a:r>
             <a:r>
-              <a:rPr lang="en-US" dirty="0"/>
+              <a:rPr lang="en-US"/>
               <a:t>, </a:t>
             </a:r>
             <a:r>
-              <a:rPr lang="en-US" dirty="0">
+              <a:rPr lang="en-US">
                 <a:hlinkClick r:id="rId7"/>
               </a:rPr>
               <a:t>Okta IRAP Report</a:t>
             </a:r>
             <a:r>
-              <a:rPr lang="en-US" dirty="0"/>
+              <a:rPr lang="en-US"/>
               <a:t>, </a:t>
             </a:r>
             <a:r>
-              <a:rPr lang="en-US" dirty="0">
+              <a:rPr lang="en-US">
                 <a:hlinkClick r:id="rId8"/>
               </a:rPr>
               <a:t>Trend Micro IRAP Report</a:t>
             </a:r>
-            <a:endParaRPr lang="en-US" dirty="0"/>
+            <a:endParaRPr lang="en-US"/>
           </a:p>
           <a:p>
             <a:pPr marL="228600" lvl="2">
@@ -50650,20 +50613,20 @@
               </a:spcBef>
             </a:pPr>
             <a:r>
-              <a:rPr lang="en-US" dirty="0"/>
+              <a:rPr lang="en-US"/>
               <a:t>Objective is get </a:t>
             </a:r>
             <a:r>
-              <a:rPr lang="en-US" dirty="0">
+              <a:rPr lang="en-US">
                 <a:hlinkClick r:id="rId9"/>
               </a:rPr>
               <a:t>Gap Assessment </a:t>
             </a:r>
             <a:r>
-              <a:rPr lang="en-US" dirty="0"/>
+              <a:rPr lang="en-US"/>
               <a:t>for Identifying the potential overhead or risks</a:t>
             </a:r>
-            <a:endParaRPr lang="en-US" b="1" dirty="0"/>
+            <a:endParaRPr lang="en-US" b="1"/>
           </a:p>
           <a:p>
             <a:pPr marL="342900" indent="-342900">
@@ -50674,7 +50637,7 @@
               <a:buAutoNum type="arabicPeriod"/>
             </a:pPr>
             <a:r>
-              <a:rPr lang="en-US" b="1" dirty="0"/>
+              <a:rPr lang="en-US" b="1"/>
               <a:t>Periodic Change by Standard Publishers (NIST, ACSC, CIS, CCCS etc.)</a:t>
             </a:r>
           </a:p>
@@ -50687,33 +50650,33 @@
               <a:buChar char="•"/>
             </a:pPr>
             <a:r>
-              <a:rPr lang="en-US" dirty="0">
+              <a:rPr lang="en-US">
                 <a:hlinkClick r:id="rId10"/>
               </a:rPr>
               <a:t>ACSC ISM Sep 2024 Release</a:t>
             </a:r>
             <a:r>
-              <a:rPr lang="en-US" dirty="0"/>
+              <a:rPr lang="en-US"/>
               <a:t>, </a:t>
             </a:r>
             <a:r>
-              <a:rPr lang="en-US" dirty="0">
+              <a:rPr lang="en-US">
                 <a:hlinkClick r:id="rId10"/>
               </a:rPr>
               <a:t>ACSC ISM Dec 2024 Release</a:t>
             </a:r>
             <a:r>
-              <a:rPr lang="en-US" dirty="0"/>
+              <a:rPr lang="en-US"/>
               <a:t>, </a:t>
             </a:r>
             <a:r>
-              <a:rPr lang="en-US" dirty="0">
+              <a:rPr lang="en-US">
                 <a:hlinkClick r:id="rId10"/>
               </a:rPr>
               <a:t>ACSC ISM Mar 2025 Release</a:t>
             </a:r>
             <a:r>
-              <a:rPr lang="en-US" dirty="0"/>
+              <a:rPr lang="en-US"/>
               <a:t>, etc. </a:t>
             </a:r>
           </a:p>
@@ -50726,7 +50689,7 @@
               <a:buChar char="•"/>
             </a:pPr>
             <a:r>
-              <a:rPr lang="en-US" dirty="0"/>
+              <a:rPr lang="en-US"/>
               <a:t>Leads to </a:t>
             </a:r>
           </a:p>
@@ -50738,7 +50701,7 @@
               <a:buFont typeface="Arial" panose="020B0604020202020204" pitchFamily="34" charset="0"/>
               <a:buChar char="•"/>
             </a:pPr>
-            <a:endParaRPr lang="en-US" dirty="0"/>
+            <a:endParaRPr lang="en-US"/>
           </a:p>
           <a:p>
             <a:pPr marL="571500" lvl="1" indent="-342900">
@@ -50748,7 +50711,7 @@
               <a:buFont typeface="Arial" panose="020B0604020202020204" pitchFamily="34" charset="0"/>
               <a:buChar char="•"/>
             </a:pPr>
-            <a:endParaRPr lang="en-US" dirty="0"/>
+            <a:endParaRPr lang="en-US"/>
           </a:p>
           <a:p>
             <a:pPr marL="571500" lvl="1" indent="-342900">
@@ -50758,7 +50721,7 @@
               <a:buFont typeface="Arial" panose="020B0604020202020204" pitchFamily="34" charset="0"/>
               <a:buChar char="•"/>
             </a:pPr>
-            <a:endParaRPr lang="en-US" dirty="0"/>
+            <a:endParaRPr lang="en-US"/>
           </a:p>
           <a:p>
             <a:pPr marL="342900" indent="-342900">
@@ -50768,7 +50731,7 @@
               <a:buFont typeface="+mj-lt"/>
               <a:buAutoNum type="arabicPeriod"/>
             </a:pPr>
-            <a:endParaRPr lang="en-US" b="1" dirty="0"/>
+            <a:endParaRPr lang="en-US" b="1"/>
           </a:p>
           <a:p>
             <a:pPr marL="285750" indent="-285750">
@@ -50778,7 +50741,7 @@
               <a:buFont typeface="Arial" panose="020B0604020202020204" pitchFamily="34" charset="0"/>
               <a:buChar char="•"/>
             </a:pPr>
-            <a:endParaRPr lang="en-US" b="1" dirty="0"/>
+            <a:endParaRPr lang="en-US" b="1"/>
           </a:p>
           <a:p>
             <a:pPr>
@@ -50786,14 +50749,14 @@
                 <a:spcPts val="2500"/>
               </a:spcBef>
             </a:pPr>
-            <a:endParaRPr lang="en-US" dirty="0"/>
+            <a:endParaRPr lang="en-US"/>
           </a:p>
           <a:p>
             <a:pPr marL="0" lvl="1" indent="0">
               <a:buFont typeface="Arial" panose="020B0604020202020204" pitchFamily="34" charset="0"/>
               <a:buNone/>
             </a:pPr>
-            <a:endParaRPr lang="en-US" dirty="0"/>
+            <a:endParaRPr lang="en-US"/>
           </a:p>
         </p:txBody>
       </p:sp>
@@ -50993,7 +50956,7 @@
           <a:lstStyle/>
           <a:p>
             <a:r>
-              <a:rPr lang="en-US" sz="6200" dirty="0"/>
+              <a:rPr lang="en-US" sz="6200"/>
               <a:t>Background on OSCAL</a:t>
             </a:r>
           </a:p>
@@ -51159,7 +51122,7 @@
           <a:lstStyle/>
           <a:p>
             <a:r>
-              <a:rPr lang="en-US" sz="3700" dirty="0"/>
+              <a:rPr lang="en-US" sz="3700"/>
               <a:t>What is OSCAL and Why It Matters</a:t>
             </a:r>
           </a:p>
@@ -51240,7 +51203,7 @@
               </a:spcBef>
             </a:pPr>
             <a:r>
-              <a:rPr lang="en-US" dirty="0"/>
+              <a:rPr lang="en-US"/>
               <a:t>OSCAL (Open Security Controls Assessment Language) is a NIST initiative to standardize the representation of security controls and compliance data.</a:t>
             </a:r>
           </a:p>
@@ -51253,7 +51216,7 @@
               <a:buNone/>
             </a:pPr>
             <a:r>
-              <a:rPr lang="en-US" b="1" dirty="0"/>
+              <a:rPr lang="en-US" b="1"/>
               <a:t>Modernizing Compliance Processes</a:t>
             </a:r>
           </a:p>
@@ -51263,10 +51226,9 @@
               <a:buNone/>
             </a:pPr>
             <a:r>
-              <a:rPr dirty="0"/>
               <a:t>OSCAL modernizes security and compliance by using machine-readable formats like XML, JSON, and YAML.</a:t>
             </a:r>
-            <a:endParaRPr lang="en-US" dirty="0"/>
+            <a:endParaRPr lang="en-US"/>
           </a:p>
           <a:p>
             <a:pPr marL="0" indent="0">
@@ -51277,7 +51239,7 @@
               <a:buNone/>
             </a:pPr>
             <a:r>
-              <a:rPr lang="en-US" b="1" dirty="0"/>
+              <a:rPr lang="en-US" b="1"/>
               <a:t>Reducing Audit Duration</a:t>
             </a:r>
           </a:p>
@@ -51287,18 +51249,16 @@
               <a:buNone/>
             </a:pPr>
             <a:r>
-              <a:rPr dirty="0"/>
               <a:t>OSCAL reduces audit times from months to </a:t>
             </a:r>
             <a:r>
-              <a:rPr lang="en-AU" dirty="0"/>
+              <a:rPr lang="en-AU"/>
               <a:t>days</a:t>
             </a:r>
             <a:r>
-              <a:rPr dirty="0"/>
               <a:t> by automating documentation and assessment workflows.</a:t>
             </a:r>
-            <a:endParaRPr lang="en-US" dirty="0"/>
+            <a:endParaRPr lang="en-US"/>
           </a:p>
           <a:p>
             <a:pPr marL="0" indent="0">
@@ -51309,7 +51269,7 @@
               <a:buNone/>
             </a:pPr>
             <a:r>
-              <a:rPr lang="en-US" b="1" dirty="0"/>
+              <a:rPr lang="en-US" b="1"/>
               <a:t>Enabling Interoperability </a:t>
             </a:r>
           </a:p>
@@ -51319,10 +51279,9 @@
               <a:buNone/>
             </a:pPr>
             <a:r>
-              <a:rPr dirty="0"/>
               <a:t>OSCAL supports interoperability across tools and frameworks, improving compliance efficiency and scalability.</a:t>
             </a:r>
-            <a:endParaRPr lang="en-US" dirty="0"/>
+            <a:endParaRPr lang="en-US"/>
           </a:p>
           <a:p>
             <a:pPr marL="0" indent="0">
@@ -51333,25 +51292,23 @@
               <a:buNone/>
             </a:pPr>
             <a:r>
-              <a:rPr lang="en-US" b="1" dirty="0"/>
+              <a:rPr lang="en-US" b="1"/>
               <a:t>Driving Global Standards</a:t>
             </a:r>
           </a:p>
           <a:p>
             <a:pPr marL="0" lvl="1"/>
             <a:r>
-              <a:rPr dirty="0"/>
               <a:t>OSCAL is adopted by regulatory bodies like FedRAMP,</a:t>
             </a:r>
             <a:r>
-              <a:rPr lang="en-US" dirty="0"/>
+              <a:rPr lang="en-US"/>
               <a:t> ACSC, Singapore Gov.</a:t>
             </a:r>
             <a:r>
-              <a:rPr dirty="0"/>
               <a:t> aiming to become a global compliance automation standard.</a:t>
             </a:r>
-            <a:endParaRPr lang="en-AU" dirty="0"/>
+            <a:endParaRPr lang="en-AU"/>
           </a:p>
           <a:p>
             <a:pPr>
@@ -51360,14 +51317,14 @@
               </a:spcBef>
             </a:pPr>
             <a:r>
-              <a:rPr lang="en-US" b="1" dirty="0"/>
+              <a:rPr lang="en-US" b="1"/>
               <a:t>Continuous Compliance Automation</a:t>
             </a:r>
           </a:p>
           <a:p>
             <a:pPr marL="0" lvl="1"/>
             <a:r>
-              <a:rPr lang="en-US" dirty="0"/>
+              <a:rPr lang="en-US"/>
               <a:t>Enables AMS to automate assessments and maintain compliance with evolving standards.</a:t>
             </a:r>
           </a:p>
@@ -51376,7 +51333,7 @@
               <a:buFont typeface="Arial" panose="020B0604020202020204" pitchFamily="34" charset="0"/>
               <a:buNone/>
             </a:pPr>
-            <a:endParaRPr lang="en-US" dirty="0"/>
+            <a:endParaRPr lang="en-US"/>
           </a:p>
         </p:txBody>
       </p:sp>
@@ -51534,7 +51491,7 @@
           <a:lstStyle/>
           <a:p>
             <a:r>
-              <a:rPr lang="en-US" sz="6800" dirty="0"/>
+              <a:rPr lang="en-US" sz="6800"/>
               <a:t>Existing Tools in Adobe</a:t>
             </a:r>
           </a:p>
@@ -52619,6 +52576,15 @@
 </file>
 
 <file path=customXml/item1.xml><?xml version="1.0" encoding="utf-8"?>
+<?mso-contentType ?>
+<FormTemplates xmlns="http://schemas.microsoft.com/sharepoint/v3/contenttype/forms">
+  <Display>DocumentLibraryForm</Display>
+  <Edit>DocumentLibraryForm</Edit>
+  <New>DocumentLibraryForm</New>
+</FormTemplates>
+</file>
+
+<file path=customXml/item2.xml><?xml version="1.0" encoding="utf-8"?>
 <ct:contentTypeSchema xmlns:ct="http://schemas.microsoft.com/office/2006/metadata/contentType" xmlns:ma="http://schemas.microsoft.com/office/2006/metadata/properties/metaAttributes" ct:_="" ma:_="" ma:contentTypeName="Document" ma:contentTypeID="0x01010079F111ED35F8CC479449609E8A0923A6" ma:contentTypeVersion="30" ma:contentTypeDescription="Create a new document." ma:contentTypeScope="" ma:versionID="cec0622158e8f13124e9e8fd4de31bd1">
   <xsd:schema xmlns:xsd="http://www.w3.org/2001/XMLSchema" xmlns:xs="http://www.w3.org/2001/XMLSchema" xmlns:p="http://schemas.microsoft.com/office/2006/metadata/properties" xmlns:ns1="http://schemas.microsoft.com/sharepoint/v3" xmlns:ns2="71af3243-3dd4-4a8d-8c0d-dd76da1f02a5" xmlns:ns3="16c05727-aa75-4e4a-9b5f-8a80a1165891" xmlns:ns4="230e9df3-be65-4c73-a93b-d1236ebd677e" targetNamespace="http://schemas.microsoft.com/office/2006/metadata/properties" ma:root="true" ma:fieldsID="3b52f30ab005d15df08657af532e6e38" ns1:_="" ns2:_="" ns3:_="" ns4:_="">
     <xsd:import namespace="http://schemas.microsoft.com/sharepoint/v3"/>
@@ -52936,7 +52902,7 @@
 </ct:contentTypeSchema>
 </file>
 
-<file path=customXml/item2.xml><?xml version="1.0" encoding="utf-8"?>
+<file path=customXml/item3.xml><?xml version="1.0" encoding="utf-8"?>
 <p:properties xmlns:p="http://schemas.microsoft.com/office/2006/metadata/properties" xmlns:xsi="http://www.w3.org/2001/XMLSchema-instance" xmlns:pc="http://schemas.microsoft.com/office/infopath/2007/PartnerControls">
   <documentManagement>
     <_ip_UnifiedCompliancePolicyUIAction xmlns="http://schemas.microsoft.com/sharepoint/v3" xsi:nil="true"/>
@@ -52956,16 +52922,15 @@
 </p:properties>
 </file>
 
-<file path=customXml/item3.xml><?xml version="1.0" encoding="utf-8"?>
-<?mso-contentType ?>
-<FormTemplates xmlns="http://schemas.microsoft.com/sharepoint/v3/contenttype/forms">
-  <Display>DocumentLibraryForm</Display>
-  <Edit>DocumentLibraryForm</Edit>
-  <New>DocumentLibraryForm</New>
-</FormTemplates>
+<file path=customXml/itemProps1.xml><?xml version="1.0" encoding="utf-8"?>
+<ds:datastoreItem xmlns:ds="http://schemas.openxmlformats.org/officeDocument/2006/customXml" ds:itemID="{38E339AF-67FC-4BA3-8B2E-038B3ED310D5}">
+  <ds:schemaRefs>
+    <ds:schemaRef ds:uri="http://schemas.microsoft.com/sharepoint/v3/contenttype/forms"/>
+  </ds:schemaRefs>
+</ds:datastoreItem>
 </file>
 
-<file path=customXml/itemProps1.xml><?xml version="1.0" encoding="utf-8"?>
+<file path=customXml/itemProps2.xml><?xml version="1.0" encoding="utf-8"?>
 <ds:datastoreItem xmlns:ds="http://schemas.openxmlformats.org/officeDocument/2006/customXml" ds:itemID="{3766CE19-BB35-48A2-AFDA-766E83330032}">
   <ds:schemaRefs>
     <ds:schemaRef ds:uri="16c05727-aa75-4e4a-9b5f-8a80a1165891"/>
@@ -52986,29 +52951,21 @@
 </ds:datastoreItem>
 </file>
 
-<file path=customXml/itemProps2.xml><?xml version="1.0" encoding="utf-8"?>
+<file path=customXml/itemProps3.xml><?xml version="1.0" encoding="utf-8"?>
 <ds:datastoreItem xmlns:ds="http://schemas.openxmlformats.org/officeDocument/2006/customXml" ds:itemID="{4B99ED26-B189-4BA1-99D0-1112D8C2F106}">
   <ds:schemaRefs>
+    <ds:schemaRef ds:uri="16c05727-aa75-4e4a-9b5f-8a80a1165891"/>
+    <ds:schemaRef ds:uri="230e9df3-be65-4c73-a93b-d1236ebd677e"/>
+    <ds:schemaRef ds:uri="71af3243-3dd4-4a8d-8c0d-dd76da1f02a5"/>
+    <ds:schemaRef ds:uri="http://purl.org/dc/dcmitype/"/>
+    <ds:schemaRef ds:uri="http://purl.org/dc/elements/1.1/"/>
+    <ds:schemaRef ds:uri="http://purl.org/dc/terms/"/>
+    <ds:schemaRef ds:uri="http://schemas.microsoft.com/office/2006/documentManagement/types"/>
     <ds:schemaRef ds:uri="http://schemas.microsoft.com/office/2006/metadata/properties"/>
+    <ds:schemaRef ds:uri="http://schemas.microsoft.com/office/infopath/2007/PartnerControls"/>
+    <ds:schemaRef ds:uri="http://schemas.microsoft.com/sharepoint/v3"/>
+    <ds:schemaRef ds:uri="http://schemas.openxmlformats.org/package/2006/metadata/core-properties"/>
     <ds:schemaRef ds:uri="http://www.w3.org/XML/1998/namespace"/>
-    <ds:schemaRef ds:uri="http://purl.org/dc/dcmitype/"/>
-    <ds:schemaRef ds:uri="http://schemas.microsoft.com/office/infopath/2007/PartnerControls"/>
-    <ds:schemaRef ds:uri="http://purl.org/dc/terms/"/>
-    <ds:schemaRef ds:uri="http://schemas.openxmlformats.org/package/2006/metadata/core-properties"/>
-    <ds:schemaRef ds:uri="http://purl.org/dc/elements/1.1/"/>
-    <ds:schemaRef ds:uri="http://schemas.microsoft.com/office/2006/documentManagement/types"/>
-    <ds:schemaRef ds:uri="230e9df3-be65-4c73-a93b-d1236ebd677e"/>
-    <ds:schemaRef ds:uri="16c05727-aa75-4e4a-9b5f-8a80a1165891"/>
-    <ds:schemaRef ds:uri="71af3243-3dd4-4a8d-8c0d-dd76da1f02a5"/>
-    <ds:schemaRef ds:uri="http://schemas.microsoft.com/sharepoint/v3"/>
-  </ds:schemaRefs>
-</ds:datastoreItem>
-</file>
-
-<file path=customXml/itemProps3.xml><?xml version="1.0" encoding="utf-8"?>
-<ds:datastoreItem xmlns:ds="http://schemas.openxmlformats.org/officeDocument/2006/customXml" ds:itemID="{38E339AF-67FC-4BA3-8B2E-038B3ED310D5}">
-  <ds:schemaRefs>
-    <ds:schemaRef ds:uri="http://schemas.microsoft.com/sharepoint/v3/contenttype/forms"/>
   </ds:schemaRefs>
 </ds:datastoreItem>
 </file>

</xml_diff>